<commit_message>
chore(privacy): strip phone from public PPT + swap to explicit test IBAN
Pre-flip-to-public sweep — removes the two pieces of public-surface
exposure that the audit flagged:

1. Slide 22 of Ajay_Antony_Capgemini_Panel_v4.pptx — removed personal
   phone "+32 489 956 432" from the Thank-you slide. Email contact
   path is retained for the panel. Anyone who needs the phone can
   ask via email.

2. tests/test_safety.py — swapped the well-known Belgian Red Cross
   donation test IBAN "BE68 5390 0754 7034" for the explicitly
   invalid "BE00 0000 0000 0000". Both match the PII regex
   (BE + 2 digits + 3 groups of 4); the second is unambiguously not
   anyone's real account. 15 safety tests pass against the new value.

3. .gitignore — added Presentation/*_v[0-9].pptx pattern so historical
   PPT versions stay local-only and don't accumulate in the public
   repo. v4 (the current) stays tracked via the negation rule.

Co-Authored-By: Claude Opus 4.7 (1M context) <noreply@anthropic.com>
</commit_message>
<xml_diff>
--- a/Presentation/Ajay_Antony_Capgemini_Panel_v4.pptx
+++ b/Presentation/Ajay_Antony_Capgemini_Panel_v4.pptx
@@ -2680,6 +2680,10 @@
             <a:prstDash val="solid"/>
           </a:ln>
         </p:spPr>
+        <p:txBody>
+          <a:bodyPr/>
+          <a:p/>
+        </p:txBody>
       </p:sp>
       <p:sp>
         <p:nvSpPr>
@@ -2971,6 +2975,10 @@
             <a:prstDash val="solid"/>
           </a:ln>
         </p:spPr>
+        <p:txBody>
+          <a:bodyPr/>
+          <a:p/>
+        </p:txBody>
       </p:sp>
       <p:sp>
         <p:nvSpPr>
@@ -3035,6 +3043,10 @@
             <a:prstDash val="solid"/>
           </a:ln>
         </p:spPr>
+        <p:txBody>
+          <a:bodyPr/>
+          <a:p/>
+        </p:txBody>
       </p:sp>
       <p:sp>
         <p:nvSpPr>
@@ -3060,6 +3072,10 @@
             <a:prstDash val="solid"/>
           </a:ln>
         </p:spPr>
+        <p:txBody>
+          <a:bodyPr/>
+          <a:p/>
+        </p:txBody>
       </p:sp>
       <p:sp>
         <p:nvSpPr>
@@ -3124,6 +3140,10 @@
             <a:prstDash val="solid"/>
           </a:ln>
         </p:spPr>
+        <p:txBody>
+          <a:bodyPr/>
+          <a:p/>
+        </p:txBody>
       </p:sp>
       <p:sp>
         <p:nvSpPr>
@@ -3188,6 +3208,10 @@
             <a:prstDash val="solid"/>
           </a:ln>
         </p:spPr>
+        <p:txBody>
+          <a:bodyPr/>
+          <a:p/>
+        </p:txBody>
       </p:sp>
       <p:sp>
         <p:nvSpPr>
@@ -3252,6 +3276,10 @@
             <a:prstDash val="solid"/>
           </a:ln>
         </p:spPr>
+        <p:txBody>
+          <a:bodyPr/>
+          <a:p/>
+        </p:txBody>
       </p:sp>
       <p:sp>
         <p:nvSpPr>
@@ -3316,6 +3344,10 @@
             <a:prstDash val="solid"/>
           </a:ln>
         </p:spPr>
+        <p:txBody>
+          <a:bodyPr/>
+          <a:p/>
+        </p:txBody>
       </p:sp>
       <p:sp>
         <p:nvSpPr>
@@ -3380,6 +3412,10 @@
             <a:prstDash val="solid"/>
           </a:ln>
         </p:spPr>
+        <p:txBody>
+          <a:bodyPr/>
+          <a:p/>
+        </p:txBody>
       </p:sp>
       <p:sp>
         <p:nvSpPr>
@@ -3405,6 +3441,10 @@
             <a:prstDash val="solid"/>
           </a:ln>
         </p:spPr>
+        <p:txBody>
+          <a:bodyPr/>
+          <a:p/>
+        </p:txBody>
       </p:sp>
       <p:sp>
         <p:nvSpPr>
@@ -3469,6 +3509,10 @@
             <a:prstDash val="solid"/>
           </a:ln>
         </p:spPr>
+        <p:txBody>
+          <a:bodyPr/>
+          <a:p/>
+        </p:txBody>
       </p:sp>
       <p:sp>
         <p:nvSpPr>
@@ -3533,6 +3577,10 @@
             <a:prstDash val="solid"/>
           </a:ln>
         </p:spPr>
+        <p:txBody>
+          <a:bodyPr/>
+          <a:p/>
+        </p:txBody>
       </p:sp>
       <p:sp>
         <p:nvSpPr>
@@ -3597,6 +3645,10 @@
             <a:prstDash val="solid"/>
           </a:ln>
         </p:spPr>
+        <p:txBody>
+          <a:bodyPr/>
+          <a:p/>
+        </p:txBody>
       </p:sp>
       <p:sp>
         <p:nvSpPr>
@@ -3661,6 +3713,10 @@
             <a:prstDash val="solid"/>
           </a:ln>
         </p:spPr>
+        <p:txBody>
+          <a:bodyPr/>
+          <a:p/>
+        </p:txBody>
       </p:sp>
       <p:sp>
         <p:nvSpPr>
@@ -3835,6 +3891,10 @@
             <a:prstDash val="solid"/>
           </a:ln>
         </p:spPr>
+        <p:txBody>
+          <a:bodyPr/>
+          <a:p/>
+        </p:txBody>
       </p:sp>
       <p:sp>
         <p:nvSpPr>
@@ -3899,6 +3959,10 @@
             <a:prstDash val="solid"/>
           </a:ln>
         </p:spPr>
+        <p:txBody>
+          <a:bodyPr/>
+          <a:p/>
+        </p:txBody>
       </p:sp>
       <p:sp>
         <p:nvSpPr>
@@ -3963,6 +4027,10 @@
             <a:prstDash val="solid"/>
           </a:ln>
         </p:spPr>
+        <p:txBody>
+          <a:bodyPr/>
+          <a:p/>
+        </p:txBody>
       </p:sp>
       <p:sp>
         <p:nvSpPr>
@@ -4026,6 +4094,10 @@
             <a:tailEnd type="triangle"/>
           </a:ln>
         </p:spPr>
+        <p:txBody>
+          <a:bodyPr/>
+          <a:p/>
+        </p:txBody>
       </p:sp>
       <p:sp>
         <p:nvSpPr>
@@ -4051,6 +4123,10 @@
             <a:prstDash val="solid"/>
           </a:ln>
         </p:spPr>
+        <p:txBody>
+          <a:bodyPr/>
+          <a:p/>
+        </p:txBody>
       </p:sp>
       <p:sp>
         <p:nvSpPr>
@@ -4153,6 +4229,10 @@
             <a:tailEnd type="triangle"/>
           </a:ln>
         </p:spPr>
+        <p:txBody>
+          <a:bodyPr/>
+          <a:p/>
+        </p:txBody>
       </p:sp>
       <p:sp>
         <p:nvSpPr>
@@ -4178,6 +4258,10 @@
             <a:prstDash val="solid"/>
           </a:ln>
         </p:spPr>
+        <p:txBody>
+          <a:bodyPr/>
+          <a:p/>
+        </p:txBody>
       </p:sp>
       <p:sp>
         <p:nvSpPr>
@@ -4280,6 +4364,10 @@
             <a:tailEnd type="triangle"/>
           </a:ln>
         </p:spPr>
+        <p:txBody>
+          <a:bodyPr/>
+          <a:p/>
+        </p:txBody>
       </p:sp>
       <p:sp>
         <p:nvSpPr>
@@ -4305,6 +4393,10 @@
             <a:prstDash val="solid"/>
           </a:ln>
         </p:spPr>
+        <p:txBody>
+          <a:bodyPr/>
+          <a:p/>
+        </p:txBody>
       </p:sp>
       <p:sp>
         <p:nvSpPr>
@@ -4407,6 +4499,10 @@
             <a:tailEnd type="triangle"/>
           </a:ln>
         </p:spPr>
+        <p:txBody>
+          <a:bodyPr/>
+          <a:p/>
+        </p:txBody>
       </p:sp>
       <p:sp>
         <p:nvSpPr>
@@ -4432,6 +4528,10 @@
             <a:prstDash val="solid"/>
           </a:ln>
         </p:spPr>
+        <p:txBody>
+          <a:bodyPr/>
+          <a:p/>
+        </p:txBody>
       </p:sp>
       <p:sp>
         <p:nvSpPr>
@@ -4534,6 +4634,10 @@
             <a:tailEnd type="triangle"/>
           </a:ln>
         </p:spPr>
+        <p:txBody>
+          <a:bodyPr/>
+          <a:p/>
+        </p:txBody>
       </p:sp>
       <p:sp>
         <p:nvSpPr>
@@ -4559,6 +4663,10 @@
             <a:prstDash val="solid"/>
           </a:ln>
         </p:spPr>
+        <p:txBody>
+          <a:bodyPr/>
+          <a:p/>
+        </p:txBody>
       </p:sp>
       <p:sp>
         <p:nvSpPr>
@@ -4661,6 +4769,10 @@
             <a:tailEnd type="triangle"/>
           </a:ln>
         </p:spPr>
+        <p:txBody>
+          <a:bodyPr/>
+          <a:p/>
+        </p:txBody>
       </p:sp>
       <p:sp>
         <p:nvSpPr>
@@ -4725,6 +4837,10 @@
             <a:prstDash val="solid"/>
           </a:ln>
         </p:spPr>
+        <p:txBody>
+          <a:bodyPr/>
+          <a:p/>
+        </p:txBody>
       </p:sp>
       <p:sp>
         <p:nvSpPr>
@@ -4828,6 +4944,10 @@
             <a:prstDash val="solid"/>
           </a:ln>
         </p:spPr>
+        <p:txBody>
+          <a:bodyPr/>
+          <a:p/>
+        </p:txBody>
       </p:sp>
       <p:sp>
         <p:nvSpPr>
@@ -4931,6 +5051,10 @@
             <a:prstDash val="solid"/>
           </a:ln>
         </p:spPr>
+        <p:txBody>
+          <a:bodyPr/>
+          <a:p/>
+        </p:txBody>
       </p:sp>
       <p:sp>
         <p:nvSpPr>
@@ -5033,6 +5157,10 @@
             <a:tailEnd type="triangle"/>
           </a:ln>
         </p:spPr>
+        <p:txBody>
+          <a:bodyPr/>
+          <a:p/>
+        </p:txBody>
       </p:sp>
       <p:sp>
         <p:nvSpPr>
@@ -5058,6 +5186,10 @@
             <a:prstDash val="solid"/>
           </a:ln>
         </p:spPr>
+        <p:txBody>
+          <a:bodyPr/>
+          <a:p/>
+        </p:txBody>
       </p:sp>
       <p:sp>
         <p:nvSpPr>
@@ -5161,6 +5293,10 @@
             <a:prstDash val="solid"/>
           </a:ln>
         </p:spPr>
+        <p:txBody>
+          <a:bodyPr/>
+          <a:p/>
+        </p:txBody>
       </p:sp>
       <p:sp>
         <p:nvSpPr>
@@ -6630,6 +6766,10 @@
             <a:prstDash val="solid"/>
           </a:ln>
         </p:spPr>
+        <p:txBody>
+          <a:bodyPr/>
+          <a:p/>
+        </p:txBody>
       </p:sp>
       <p:sp>
         <p:nvSpPr>
@@ -6694,6 +6834,10 @@
             <a:prstDash val="solid"/>
           </a:ln>
         </p:spPr>
+        <p:txBody>
+          <a:bodyPr/>
+          <a:p/>
+        </p:txBody>
       </p:sp>
       <p:sp>
         <p:nvSpPr>
@@ -6719,6 +6863,10 @@
             <a:prstDash val="solid"/>
           </a:ln>
         </p:spPr>
+        <p:txBody>
+          <a:bodyPr/>
+          <a:p/>
+        </p:txBody>
       </p:sp>
       <p:sp>
         <p:nvSpPr>
@@ -6783,6 +6931,10 @@
             <a:prstDash val="solid"/>
           </a:ln>
         </p:spPr>
+        <p:txBody>
+          <a:bodyPr/>
+          <a:p/>
+        </p:txBody>
       </p:sp>
       <p:sp>
         <p:nvSpPr>
@@ -6847,6 +6999,10 @@
             <a:prstDash val="solid"/>
           </a:ln>
         </p:spPr>
+        <p:txBody>
+          <a:bodyPr/>
+          <a:p/>
+        </p:txBody>
       </p:sp>
       <p:sp>
         <p:nvSpPr>
@@ -6911,6 +7067,10 @@
             <a:prstDash val="solid"/>
           </a:ln>
         </p:spPr>
+        <p:txBody>
+          <a:bodyPr/>
+          <a:p/>
+        </p:txBody>
       </p:sp>
       <p:sp>
         <p:nvSpPr>
@@ -6975,6 +7135,10 @@
             <a:prstDash val="solid"/>
           </a:ln>
         </p:spPr>
+        <p:txBody>
+          <a:bodyPr/>
+          <a:p/>
+        </p:txBody>
       </p:sp>
       <p:sp>
         <p:nvSpPr>
@@ -7039,6 +7203,10 @@
             <a:prstDash val="solid"/>
           </a:ln>
         </p:spPr>
+        <p:txBody>
+          <a:bodyPr/>
+          <a:p/>
+        </p:txBody>
       </p:sp>
       <p:sp>
         <p:nvSpPr>
@@ -7103,6 +7271,10 @@
             <a:prstDash val="solid"/>
           </a:ln>
         </p:spPr>
+        <p:txBody>
+          <a:bodyPr/>
+          <a:p/>
+        </p:txBody>
       </p:sp>
       <p:sp>
         <p:nvSpPr>
@@ -7128,6 +7300,10 @@
             <a:prstDash val="solid"/>
           </a:ln>
         </p:spPr>
+        <p:txBody>
+          <a:bodyPr/>
+          <a:p/>
+        </p:txBody>
       </p:sp>
       <p:sp>
         <p:nvSpPr>
@@ -7192,6 +7368,10 @@
             <a:prstDash val="solid"/>
           </a:ln>
         </p:spPr>
+        <p:txBody>
+          <a:bodyPr/>
+          <a:p/>
+        </p:txBody>
       </p:sp>
       <p:sp>
         <p:nvSpPr>
@@ -7256,6 +7436,10 @@
             <a:prstDash val="solid"/>
           </a:ln>
         </p:spPr>
+        <p:txBody>
+          <a:bodyPr/>
+          <a:p/>
+        </p:txBody>
       </p:sp>
       <p:sp>
         <p:nvSpPr>
@@ -7320,6 +7504,10 @@
             <a:prstDash val="solid"/>
           </a:ln>
         </p:spPr>
+        <p:txBody>
+          <a:bodyPr/>
+          <a:p/>
+        </p:txBody>
       </p:sp>
       <p:sp>
         <p:nvSpPr>
@@ -7384,6 +7572,10 @@
             <a:prstDash val="solid"/>
           </a:ln>
         </p:spPr>
+        <p:txBody>
+          <a:bodyPr/>
+          <a:p/>
+        </p:txBody>
       </p:sp>
       <p:sp>
         <p:nvSpPr>
@@ -7448,6 +7640,10 @@
             <a:prstDash val="solid"/>
           </a:ln>
         </p:spPr>
+        <p:txBody>
+          <a:bodyPr/>
+          <a:p/>
+        </p:txBody>
       </p:sp>
       <p:sp>
         <p:nvSpPr>
@@ -7622,6 +7818,10 @@
             <a:prstDash val="solid"/>
           </a:ln>
         </p:spPr>
+        <p:txBody>
+          <a:bodyPr/>
+          <a:p/>
+        </p:txBody>
       </p:sp>
       <p:sp>
         <p:nvSpPr>
@@ -7686,6 +7886,10 @@
             <a:prstDash val="solid"/>
           </a:ln>
         </p:spPr>
+        <p:txBody>
+          <a:bodyPr/>
+          <a:p/>
+        </p:txBody>
       </p:sp>
       <p:sp>
         <p:nvSpPr>
@@ -7711,6 +7915,10 @@
             <a:prstDash val="solid"/>
           </a:ln>
         </p:spPr>
+        <p:txBody>
+          <a:bodyPr/>
+          <a:p/>
+        </p:txBody>
       </p:sp>
       <p:sp>
         <p:nvSpPr>
@@ -7775,6 +7983,10 @@
             <a:prstDash val="solid"/>
           </a:ln>
         </p:spPr>
+        <p:txBody>
+          <a:bodyPr/>
+          <a:p/>
+        </p:txBody>
       </p:sp>
       <p:sp>
         <p:nvSpPr>
@@ -7839,6 +8051,10 @@
             <a:prstDash val="solid"/>
           </a:ln>
         </p:spPr>
+        <p:txBody>
+          <a:bodyPr/>
+          <a:p/>
+        </p:txBody>
       </p:sp>
       <p:sp>
         <p:nvSpPr>
@@ -7903,6 +8119,10 @@
             <a:prstDash val="solid"/>
           </a:ln>
         </p:spPr>
+        <p:txBody>
+          <a:bodyPr/>
+          <a:p/>
+        </p:txBody>
       </p:sp>
       <p:sp>
         <p:nvSpPr>
@@ -7967,6 +8187,10 @@
             <a:prstDash val="solid"/>
           </a:ln>
         </p:spPr>
+        <p:txBody>
+          <a:bodyPr/>
+          <a:p/>
+        </p:txBody>
       </p:sp>
       <p:sp>
         <p:nvSpPr>
@@ -7992,6 +8216,10 @@
             <a:prstDash val="solid"/>
           </a:ln>
         </p:spPr>
+        <p:txBody>
+          <a:bodyPr/>
+          <a:p/>
+        </p:txBody>
       </p:sp>
       <p:sp>
         <p:nvSpPr>
@@ -8056,6 +8284,10 @@
             <a:prstDash val="solid"/>
           </a:ln>
         </p:spPr>
+        <p:txBody>
+          <a:bodyPr/>
+          <a:p/>
+        </p:txBody>
       </p:sp>
       <p:sp>
         <p:nvSpPr>
@@ -8120,6 +8352,10 @@
             <a:prstDash val="solid"/>
           </a:ln>
         </p:spPr>
+        <p:txBody>
+          <a:bodyPr/>
+          <a:p/>
+        </p:txBody>
       </p:sp>
       <p:sp>
         <p:nvSpPr>
@@ -8184,6 +8420,10 @@
             <a:prstDash val="solid"/>
           </a:ln>
         </p:spPr>
+        <p:txBody>
+          <a:bodyPr/>
+          <a:p/>
+        </p:txBody>
       </p:sp>
       <p:sp>
         <p:nvSpPr>
@@ -8248,6 +8488,10 @@
             <a:prstDash val="solid"/>
           </a:ln>
         </p:spPr>
+        <p:txBody>
+          <a:bodyPr/>
+          <a:p/>
+        </p:txBody>
       </p:sp>
       <p:sp>
         <p:nvSpPr>
@@ -8273,6 +8517,10 @@
             <a:prstDash val="solid"/>
           </a:ln>
         </p:spPr>
+        <p:txBody>
+          <a:bodyPr/>
+          <a:p/>
+        </p:txBody>
       </p:sp>
       <p:sp>
         <p:nvSpPr>
@@ -8337,6 +8585,10 @@
             <a:prstDash val="solid"/>
           </a:ln>
         </p:spPr>
+        <p:txBody>
+          <a:bodyPr/>
+          <a:p/>
+        </p:txBody>
       </p:sp>
       <p:sp>
         <p:nvSpPr>
@@ -8401,6 +8653,10 @@
             <a:prstDash val="solid"/>
           </a:ln>
         </p:spPr>
+        <p:txBody>
+          <a:bodyPr/>
+          <a:p/>
+        </p:txBody>
       </p:sp>
       <p:sp>
         <p:nvSpPr>
@@ -8465,6 +8721,10 @@
             <a:prstDash val="solid"/>
           </a:ln>
         </p:spPr>
+        <p:txBody>
+          <a:bodyPr/>
+          <a:p/>
+        </p:txBody>
       </p:sp>
       <p:sp>
         <p:nvSpPr>
@@ -10714,6 +10974,10 @@
             <a:prstDash val="solid"/>
           </a:ln>
         </p:spPr>
+        <p:txBody>
+          <a:bodyPr/>
+          <a:p/>
+        </p:txBody>
       </p:sp>
       <p:sp>
         <p:nvSpPr>
@@ -10778,6 +11042,10 @@
             <a:prstDash val="solid"/>
           </a:ln>
         </p:spPr>
+        <p:txBody>
+          <a:bodyPr/>
+          <a:p/>
+        </p:txBody>
       </p:sp>
       <p:sp>
         <p:nvSpPr>
@@ -10803,6 +11071,10 @@
             <a:prstDash val="solid"/>
           </a:ln>
         </p:spPr>
+        <p:txBody>
+          <a:bodyPr/>
+          <a:p/>
+        </p:txBody>
       </p:sp>
       <p:sp>
         <p:nvSpPr>
@@ -10867,6 +11139,10 @@
             <a:prstDash val="solid"/>
           </a:ln>
         </p:spPr>
+        <p:txBody>
+          <a:bodyPr/>
+          <a:p/>
+        </p:txBody>
       </p:sp>
       <p:sp>
         <p:nvSpPr>
@@ -10931,6 +11207,10 @@
             <a:prstDash val="solid"/>
           </a:ln>
         </p:spPr>
+        <p:txBody>
+          <a:bodyPr/>
+          <a:p/>
+        </p:txBody>
       </p:sp>
       <p:sp>
         <p:nvSpPr>
@@ -10995,6 +11275,10 @@
             <a:prstDash val="solid"/>
           </a:ln>
         </p:spPr>
+        <p:txBody>
+          <a:bodyPr/>
+          <a:p/>
+        </p:txBody>
       </p:sp>
       <p:sp>
         <p:nvSpPr>
@@ -11059,6 +11343,10 @@
             <a:prstDash val="solid"/>
           </a:ln>
         </p:spPr>
+        <p:txBody>
+          <a:bodyPr/>
+          <a:p/>
+        </p:txBody>
       </p:sp>
       <p:sp>
         <p:nvSpPr>
@@ -11123,6 +11411,10 @@
             <a:prstDash val="solid"/>
           </a:ln>
         </p:spPr>
+        <p:txBody>
+          <a:bodyPr/>
+          <a:p/>
+        </p:txBody>
       </p:sp>
       <p:sp>
         <p:nvSpPr>
@@ -11148,6 +11440,10 @@
             <a:prstDash val="solid"/>
           </a:ln>
         </p:spPr>
+        <p:txBody>
+          <a:bodyPr/>
+          <a:p/>
+        </p:txBody>
       </p:sp>
       <p:sp>
         <p:nvSpPr>
@@ -11212,6 +11508,10 @@
             <a:prstDash val="solid"/>
           </a:ln>
         </p:spPr>
+        <p:txBody>
+          <a:bodyPr/>
+          <a:p/>
+        </p:txBody>
       </p:sp>
       <p:sp>
         <p:nvSpPr>
@@ -11276,6 +11576,10 @@
             <a:prstDash val="solid"/>
           </a:ln>
         </p:spPr>
+        <p:txBody>
+          <a:bodyPr/>
+          <a:p/>
+        </p:txBody>
       </p:sp>
       <p:sp>
         <p:nvSpPr>
@@ -11340,6 +11644,10 @@
             <a:prstDash val="solid"/>
           </a:ln>
         </p:spPr>
+        <p:txBody>
+          <a:bodyPr/>
+          <a:p/>
+        </p:txBody>
       </p:sp>
       <p:sp>
         <p:nvSpPr>
@@ -11404,6 +11712,10 @@
             <a:prstDash val="solid"/>
           </a:ln>
         </p:spPr>
+        <p:txBody>
+          <a:bodyPr/>
+          <a:p/>
+        </p:txBody>
       </p:sp>
       <p:sp>
         <p:nvSpPr>
@@ -11468,6 +11780,10 @@
             <a:prstDash val="solid"/>
           </a:ln>
         </p:spPr>
+        <p:txBody>
+          <a:bodyPr/>
+          <a:p/>
+        </p:txBody>
       </p:sp>
       <p:sp>
         <p:nvSpPr>
@@ -11532,6 +11848,10 @@
             <a:prstDash val="solid"/>
           </a:ln>
         </p:spPr>
+        <p:txBody>
+          <a:bodyPr/>
+          <a:p/>
+        </p:txBody>
       </p:sp>
       <p:sp>
         <p:nvSpPr>
@@ -11557,6 +11877,10 @@
             <a:prstDash val="solid"/>
           </a:ln>
         </p:spPr>
+        <p:txBody>
+          <a:bodyPr/>
+          <a:p/>
+        </p:txBody>
       </p:sp>
       <p:sp>
         <p:nvSpPr>
@@ -11621,6 +11945,10 @@
             <a:prstDash val="solid"/>
           </a:ln>
         </p:spPr>
+        <p:txBody>
+          <a:bodyPr/>
+          <a:p/>
+        </p:txBody>
       </p:sp>
       <p:sp>
         <p:nvSpPr>
@@ -11685,6 +12013,10 @@
             <a:prstDash val="solid"/>
           </a:ln>
         </p:spPr>
+        <p:txBody>
+          <a:bodyPr/>
+          <a:p/>
+        </p:txBody>
       </p:sp>
       <p:sp>
         <p:nvSpPr>
@@ -11749,6 +12081,10 @@
             <a:prstDash val="solid"/>
           </a:ln>
         </p:spPr>
+        <p:txBody>
+          <a:bodyPr/>
+          <a:p/>
+        </p:txBody>
       </p:sp>
       <p:sp>
         <p:nvSpPr>
@@ -13297,577 +13633,123 @@
 </file>
 
 <file path=ppt/slides/slide19.xml><?xml version="1.0" encoding="utf-8"?>
-<p:sld xmlns:a="http://schemas.openxmlformats.org/drawingml/2006/main" xmlns:r="http://schemas.openxmlformats.org/officeDocument/2006/relationships" xmlns:p="http://schemas.openxmlformats.org/presentationml/2006/main">
-  <p:cSld name="Slide 19">
-    <p:bg>
-      <p:bgPr>
-        <a:solidFill>
-          <a:srgbClr val="FFFFFF"/>
-        </a:solidFill>
-      </p:bgPr>
-    </p:bg>
+<p:sld xmlns:a="http://schemas.openxmlformats.org/drawingml/2006/main" xmlns:p="http://schemas.openxmlformats.org/presentationml/2006/main" xmlns:r="http://schemas.openxmlformats.org/officeDocument/2006/relationships">
+  <p:cSld>
     <p:spTree>
       <p:nvGrpSpPr>
         <p:cNvPr id="1" name=""/>
         <p:cNvGrpSpPr/>
         <p:nvPr/>
       </p:nvGrpSpPr>
-      <p:grpSpPr>
-        <a:xfrm>
-          <a:off x="0" y="0"/>
-          <a:ext cx="0" cy="0"/>
-          <a:chOff x="0" y="0"/>
-          <a:chExt cx="0" cy="0"/>
-        </a:xfrm>
-      </p:grpSpPr>
-      <p:sp>
-        <p:nvSpPr>
-          <p:cNvPr id="2" name="Shape 0"/>
-          <p:cNvSpPr/>
-          <p:nvPr/>
-        </p:nvSpPr>
-        <p:spPr>
-          <a:xfrm>
-            <a:off x="457200" y="502920"/>
-            <a:ext cx="73152" cy="640080"/>
-          </a:xfrm>
-          <a:prstGeom prst="rect">
-            <a:avLst/>
-          </a:prstGeom>
-          <a:solidFill>
-            <a:srgbClr val="0EA5A5"/>
-          </a:solidFill>
-          <a:ln w="12700">
-            <a:solidFill>
-              <a:srgbClr val="0EA5A5"/>
-            </a:solidFill>
-            <a:prstDash val="solid"/>
-          </a:ln>
-        </p:spPr>
-      </p:sp>
-      <p:sp>
-        <p:nvSpPr>
-          <p:cNvPr id="3" name="Text 1"/>
-          <p:cNvSpPr/>
-          <p:nvPr/>
-        </p:nvSpPr>
-        <p:spPr>
-          <a:xfrm>
-            <a:off x="685800" y="457200"/>
-            <a:ext cx="11018520" cy="731520"/>
-          </a:xfrm>
-          <a:prstGeom prst="rect">
-            <a:avLst/>
-          </a:prstGeom>
-          <a:noFill/>
-          <a:ln/>
-        </p:spPr>
-        <p:txBody>
-          <a:bodyPr wrap="square" lIns="0" tIns="0" rIns="0" bIns="0" rtlCol="0" anchor="ctr"/>
-          <a:lstStyle/>
-          <a:p>
-            <a:pPr algn="l" indent="0" marL="0">
-              <a:buNone/>
-            </a:pPr>
-            <a:r>
-              <a:rPr lang="en-US" sz="3000" b="1" dirty="0">
-                <a:solidFill>
-                  <a:srgbClr val="0F172A"/>
-                </a:solidFill>
-                <a:latin typeface="Calibri" pitchFamily="34" charset="0"/>
-                <a:ea typeface="Calibri" pitchFamily="34" charset="-122"/>
-                <a:cs typeface="Calibri" pitchFamily="34" charset="-120"/>
-              </a:rPr>
-              <a:t>Greatest achievement</a:t>
-            </a:r>
-            <a:endParaRPr lang="en-US" sz="3000" dirty="0"/>
-          </a:p>
-        </p:txBody>
-      </p:sp>
-      <p:sp>
-        <p:nvSpPr>
-          <p:cNvPr id="4" name="Shape 2"/>
-          <p:cNvSpPr/>
-          <p:nvPr/>
-        </p:nvSpPr>
-        <p:spPr>
-          <a:xfrm>
-            <a:off x="548640" y="1554480"/>
-            <a:ext cx="5120640" cy="4572000"/>
-          </a:xfrm>
-          <a:prstGeom prst="rect">
-            <a:avLst/>
-          </a:prstGeom>
-          <a:solidFill>
-            <a:srgbClr val="0B1E3F"/>
-          </a:solidFill>
-          <a:ln w="12700">
-            <a:solidFill>
-              <a:srgbClr val="0B1E3F"/>
-            </a:solidFill>
-            <a:prstDash val="solid"/>
-          </a:ln>
-        </p:spPr>
-      </p:sp>
-      <p:sp>
-        <p:nvSpPr>
-          <p:cNvPr id="5" name="Shape 3"/>
-          <p:cNvSpPr/>
-          <p:nvPr/>
-        </p:nvSpPr>
-        <p:spPr>
-          <a:xfrm>
-            <a:off x="548640" y="1554480"/>
-            <a:ext cx="73152" cy="4572000"/>
-          </a:xfrm>
-          <a:prstGeom prst="rect">
-            <a:avLst/>
-          </a:prstGeom>
-          <a:solidFill>
-            <a:srgbClr val="0EA5A5"/>
-          </a:solidFill>
-          <a:ln w="12700">
-            <a:solidFill>
-              <a:srgbClr val="0EA5A5"/>
-            </a:solidFill>
-            <a:prstDash val="solid"/>
-          </a:ln>
-        </p:spPr>
-      </p:sp>
-      <p:sp>
-        <p:nvSpPr>
-          <p:cNvPr id="6" name="Text 4"/>
-          <p:cNvSpPr/>
-          <p:nvPr/>
-        </p:nvSpPr>
-        <p:spPr>
-          <a:xfrm>
-            <a:off x="914400" y="2194560"/>
-            <a:ext cx="4572000" cy="1371600"/>
-          </a:xfrm>
-          <a:prstGeom prst="rect">
-            <a:avLst/>
-          </a:prstGeom>
-          <a:noFill/>
-          <a:ln/>
-        </p:spPr>
-        <p:txBody>
-          <a:bodyPr wrap="square" lIns="0" tIns="0" rIns="0" bIns="0" rtlCol="0" anchor="ctr"/>
-          <a:lstStyle/>
-          <a:p>
-            <a:pPr algn="l" indent="0" marL="0">
-              <a:buNone/>
-            </a:pPr>
-            <a:r>
-              <a:rPr lang="en-US" sz="5400" b="1" dirty="0">
-                <a:solidFill>
-                  <a:srgbClr val="FFFFFF"/>
-                </a:solidFill>
-                <a:latin typeface="Calibri" pitchFamily="34" charset="0"/>
-                <a:ea typeface="Calibri" pitchFamily="34" charset="-122"/>
-                <a:cs typeface="Calibri" pitchFamily="34" charset="-120"/>
-              </a:rPr>
-              <a:t>0  to  Production</a:t>
-            </a:r>
-            <a:endParaRPr lang="en-US" sz="5400" dirty="0"/>
-          </a:p>
-        </p:txBody>
-      </p:sp>
-      <p:sp>
-        <p:nvSpPr>
-          <p:cNvPr id="7" name="Text 5"/>
-          <p:cNvSpPr/>
-          <p:nvPr/>
-        </p:nvSpPr>
-        <p:spPr>
-          <a:xfrm>
-            <a:off x="914400" y="3566160"/>
-            <a:ext cx="4572000" cy="731520"/>
-          </a:xfrm>
-          <a:prstGeom prst="rect">
-            <a:avLst/>
-          </a:prstGeom>
-          <a:noFill/>
-          <a:ln/>
-        </p:spPr>
-        <p:txBody>
-          <a:bodyPr wrap="square" lIns="0" tIns="0" rIns="0" bIns="0" rtlCol="0" anchor="ctr"/>
-          <a:lstStyle/>
-          <a:p>
-            <a:pPr algn="l" indent="0" marL="0">
-              <a:buNone/>
-            </a:pPr>
-            <a:r>
-              <a:rPr lang="en-US" sz="3000" dirty="0">
-                <a:solidFill>
-                  <a:srgbClr val="0EA5A5"/>
-                </a:solidFill>
-                <a:latin typeface="Calibri" pitchFamily="34" charset="0"/>
-                <a:ea typeface="Calibri" pitchFamily="34" charset="-122"/>
-                <a:cs typeface="Calibri" pitchFamily="34" charset="-120"/>
-              </a:rPr>
-              <a:t>in under 2 months</a:t>
-            </a:r>
-            <a:endParaRPr lang="en-US" sz="3000" dirty="0"/>
-          </a:p>
-        </p:txBody>
-      </p:sp>
-      <p:sp>
-        <p:nvSpPr>
-          <p:cNvPr id="8" name="Text 6"/>
-          <p:cNvSpPr/>
-          <p:nvPr/>
-        </p:nvSpPr>
-        <p:spPr>
-          <a:xfrm>
-            <a:off x="914400" y="4389120"/>
-            <a:ext cx="4572000" cy="731520"/>
-          </a:xfrm>
-          <a:prstGeom prst="rect">
-            <a:avLst/>
-          </a:prstGeom>
-          <a:noFill/>
-          <a:ln/>
-        </p:spPr>
-        <p:txBody>
-          <a:bodyPr wrap="square" lIns="0" tIns="0" rIns="0" bIns="0" rtlCol="0" anchor="ctr"/>
-          <a:lstStyle/>
-          <a:p>
-            <a:pPr algn="l" indent="0" marL="0">
-              <a:buNone/>
-            </a:pPr>
-            <a:r>
-              <a:rPr lang="en-US" sz="3000" i="1" dirty="0">
-                <a:solidFill>
-                  <a:srgbClr val="94A3B8"/>
-                </a:solidFill>
-                <a:latin typeface="Calibri" pitchFamily="34" charset="0"/>
-                <a:ea typeface="Calibri" pitchFamily="34" charset="-122"/>
-                <a:cs typeface="Calibri" pitchFamily="34" charset="-120"/>
-              </a:rPr>
-              <a:t>solo</a:t>
-            </a:r>
-            <a:endParaRPr lang="en-US" sz="3000" dirty="0"/>
-          </a:p>
-        </p:txBody>
-      </p:sp>
-      <p:sp>
-        <p:nvSpPr>
-          <p:cNvPr id="9" name="Shape 7"/>
-          <p:cNvSpPr/>
-          <p:nvPr/>
-        </p:nvSpPr>
-        <p:spPr>
-          <a:xfrm>
-            <a:off x="5943600" y="1554480"/>
-            <a:ext cx="5669280" cy="4572000"/>
-          </a:xfrm>
-          <a:prstGeom prst="rect">
-            <a:avLst/>
-          </a:prstGeom>
-          <a:solidFill>
-            <a:srgbClr val="F8FAFC"/>
-          </a:solidFill>
-          <a:ln w="12700">
-            <a:solidFill>
-              <a:srgbClr val="E2E8F0"/>
-            </a:solidFill>
-            <a:prstDash val="solid"/>
-          </a:ln>
-        </p:spPr>
-      </p:sp>
-      <p:sp>
-        <p:nvSpPr>
-          <p:cNvPr id="10" name="Shape 8"/>
-          <p:cNvSpPr/>
-          <p:nvPr/>
-        </p:nvSpPr>
-        <p:spPr>
-          <a:xfrm>
-            <a:off x="5943600" y="1554480"/>
-            <a:ext cx="73152" cy="4572000"/>
-          </a:xfrm>
-          <a:prstGeom prst="rect">
-            <a:avLst/>
-          </a:prstGeom>
-          <a:solidFill>
-            <a:srgbClr val="0EA5A5"/>
-          </a:solidFill>
-          <a:ln w="12700">
-            <a:solidFill>
-              <a:srgbClr val="0EA5A5"/>
-            </a:solidFill>
-            <a:prstDash val="solid"/>
-          </a:ln>
-        </p:spPr>
-      </p:sp>
-      <p:sp>
-        <p:nvSpPr>
-          <p:cNvPr id="11" name="Shape 9"/>
-          <p:cNvSpPr/>
-          <p:nvPr/>
-        </p:nvSpPr>
-        <p:spPr>
-          <a:xfrm>
-            <a:off x="6236208" y="2207895"/>
-            <a:ext cx="109728" cy="109728"/>
-          </a:xfrm>
-          <a:prstGeom prst="ellipse">
-            <a:avLst/>
-          </a:prstGeom>
-          <a:solidFill>
-            <a:srgbClr val="0EA5A5"/>
-          </a:solidFill>
-          <a:ln w="12700">
-            <a:solidFill>
-              <a:srgbClr val="0EA5A5"/>
-            </a:solidFill>
-            <a:prstDash val="solid"/>
-          </a:ln>
-        </p:spPr>
-      </p:sp>
-      <p:sp>
-        <p:nvSpPr>
-          <p:cNvPr id="12" name="Text 10"/>
-          <p:cNvSpPr/>
-          <p:nvPr/>
-        </p:nvSpPr>
-        <p:spPr>
-          <a:xfrm>
-            <a:off x="6473952" y="2103120"/>
-            <a:ext cx="4956048" cy="1143000"/>
-          </a:xfrm>
-          <a:prstGeom prst="rect">
-            <a:avLst/>
-          </a:prstGeom>
-          <a:noFill/>
-          <a:ln/>
-        </p:spPr>
-        <p:txBody>
-          <a:bodyPr wrap="square" lIns="0" tIns="0" rIns="0" bIns="0" rtlCol="0" anchor="t"/>
-          <a:lstStyle/>
-          <a:p>
-            <a:pPr algn="l" indent="0" marL="0">
-              <a:buNone/>
-            </a:pPr>
-            <a:r>
-              <a:rPr lang="en-US" sz="1500" dirty="0">
-                <a:solidFill>
-                  <a:srgbClr val="0F172A"/>
-                </a:solidFill>
-                <a:latin typeface="Calibri" pitchFamily="34" charset="0"/>
-                <a:ea typeface="Calibri" pitchFamily="34" charset="-122"/>
-                <a:cs typeface="Calibri" pitchFamily="34" charset="-120"/>
-              </a:rPr>
-              <a:t>Scope: Platform that would normally be a squad's quarter</a:t>
-            </a:r>
-            <a:endParaRPr lang="en-US" sz="1500" dirty="0"/>
-          </a:p>
-        </p:txBody>
-      </p:sp>
-      <p:sp>
-        <p:nvSpPr>
-          <p:cNvPr id="13" name="Shape 11"/>
-          <p:cNvSpPr/>
-          <p:nvPr/>
-        </p:nvSpPr>
-        <p:spPr>
-          <a:xfrm>
-            <a:off x="6236208" y="3350895"/>
-            <a:ext cx="109728" cy="109728"/>
-          </a:xfrm>
-          <a:prstGeom prst="ellipse">
-            <a:avLst/>
-          </a:prstGeom>
-          <a:solidFill>
-            <a:srgbClr val="0EA5A5"/>
-          </a:solidFill>
-          <a:ln w="12700">
-            <a:solidFill>
-              <a:srgbClr val="0EA5A5"/>
-            </a:solidFill>
-            <a:prstDash val="solid"/>
-          </a:ln>
-        </p:spPr>
-      </p:sp>
-      <p:sp>
-        <p:nvSpPr>
-          <p:cNvPr id="14" name="Text 12"/>
-          <p:cNvSpPr/>
-          <p:nvPr/>
-        </p:nvSpPr>
-        <p:spPr>
-          <a:xfrm>
-            <a:off x="6473952" y="3246120"/>
-            <a:ext cx="4956048" cy="1143000"/>
-          </a:xfrm>
-          <a:prstGeom prst="rect">
-            <a:avLst/>
-          </a:prstGeom>
-          <a:noFill/>
-          <a:ln/>
-        </p:spPr>
-        <p:txBody>
-          <a:bodyPr wrap="square" lIns="0" tIns="0" rIns="0" bIns="0" rtlCol="0" anchor="t"/>
-          <a:lstStyle/>
-          <a:p>
-            <a:pPr algn="l" indent="0" marL="0">
-              <a:buNone/>
-            </a:pPr>
-            <a:r>
-              <a:rPr lang="en-US" sz="1500" dirty="0">
-                <a:solidFill>
-                  <a:srgbClr val="0F172A"/>
-                </a:solidFill>
-                <a:latin typeface="Calibri" pitchFamily="34" charset="0"/>
-                <a:ea typeface="Calibri" pitchFamily="34" charset="-122"/>
-                <a:cs typeface="Calibri" pitchFamily="34" charset="-120"/>
-              </a:rPr>
-              <a:t>Constraint: Solo engineering, new business domain, two-month window</a:t>
-            </a:r>
-            <a:endParaRPr lang="en-US" sz="1500" dirty="0"/>
-          </a:p>
-        </p:txBody>
-      </p:sp>
-      <p:sp>
-        <p:nvSpPr>
-          <p:cNvPr id="15" name="Shape 13"/>
-          <p:cNvSpPr/>
-          <p:nvPr/>
-        </p:nvSpPr>
-        <p:spPr>
-          <a:xfrm>
-            <a:off x="6236208" y="4493895"/>
-            <a:ext cx="109728" cy="109728"/>
-          </a:xfrm>
-          <a:prstGeom prst="ellipse">
-            <a:avLst/>
-          </a:prstGeom>
-          <a:solidFill>
-            <a:srgbClr val="0EA5A5"/>
-          </a:solidFill>
-          <a:ln w="12700">
-            <a:solidFill>
-              <a:srgbClr val="0EA5A5"/>
-            </a:solidFill>
-            <a:prstDash val="solid"/>
-          </a:ln>
-        </p:spPr>
-      </p:sp>
-      <p:sp>
-        <p:nvSpPr>
-          <p:cNvPr id="16" name="Text 14"/>
-          <p:cNvSpPr/>
-          <p:nvPr/>
-        </p:nvSpPr>
-        <p:spPr>
-          <a:xfrm>
-            <a:off x="6473952" y="4389120"/>
-            <a:ext cx="4956048" cy="1143000"/>
-          </a:xfrm>
-          <a:prstGeom prst="rect">
-            <a:avLst/>
-          </a:prstGeom>
-          <a:noFill/>
-          <a:ln/>
-        </p:spPr>
-        <p:txBody>
-          <a:bodyPr wrap="square" lIns="0" tIns="0" rIns="0" bIns="0" rtlCol="0" anchor="t"/>
-          <a:lstStyle/>
-          <a:p>
-            <a:pPr algn="l" indent="0" marL="0">
-              <a:buNone/>
-            </a:pPr>
-            <a:r>
-              <a:rPr lang="en-US" sz="1500" dirty="0">
-                <a:solidFill>
-                  <a:srgbClr val="0F172A"/>
-                </a:solidFill>
-                <a:latin typeface="Calibri" pitchFamily="34" charset="0"/>
-                <a:ea typeface="Calibri" pitchFamily="34" charset="-122"/>
-                <a:cs typeface="Calibri" pitchFamily="34" charset="-120"/>
-              </a:rPr>
-              <a:t>Result: Production live; written recognition from client and Infosys leadership</a:t>
-            </a:r>
-            <a:endParaRPr lang="en-US" sz="1500" dirty="0"/>
-          </a:p>
-        </p:txBody>
-      </p:sp>
-      <p:sp>
-        <p:nvSpPr>
-          <p:cNvPr id="17" name="Text 15"/>
-          <p:cNvSpPr/>
-          <p:nvPr/>
-        </p:nvSpPr>
-        <p:spPr>
-          <a:xfrm>
-            <a:off x="457200" y="6492240"/>
-            <a:ext cx="10789920" cy="274320"/>
-          </a:xfrm>
-          <a:prstGeom prst="rect">
-            <a:avLst/>
-          </a:prstGeom>
-          <a:noFill/>
-          <a:ln/>
-        </p:spPr>
-        <p:txBody>
-          <a:bodyPr wrap="square" lIns="0" tIns="0" rIns="0" bIns="0" rtlCol="0" anchor="ctr"/>
-          <a:lstStyle/>
-          <a:p>
-            <a:pPr algn="l" indent="0" marL="0">
-              <a:buNone/>
-            </a:pPr>
-            <a:r>
-              <a:rPr lang="en-US" sz="1000" dirty="0">
-                <a:solidFill>
-                  <a:srgbClr val="64748B"/>
-                </a:solidFill>
-                <a:latin typeface="Calibri" pitchFamily="34" charset="0"/>
-                <a:ea typeface="Calibri" pitchFamily="34" charset="-122"/>
-                <a:cs typeface="Calibri" pitchFamily="34" charset="-120"/>
-              </a:rPr>
+      <p:grpSpPr/>
+      <p:sp>
+        <p:nvSpPr>
+          <p:cNvPr id="2" name="TextBox 1"/>
+          <p:cNvSpPr txBox="1"/>
+          <p:nvPr/>
+        </p:nvSpPr>
+        <p:spPr>
+          <a:xfrm>
+            <a:off x="457200" y="365760"/>
+            <a:ext cx="10972800" cy="822960"/>
+          </a:xfrm>
+          <a:prstGeom prst="rect">
+            <a:avLst/>
+          </a:prstGeom>
+          <a:noFill/>
+        </p:spPr>
+        <p:txBody>
+          <a:bodyPr wrap="none">
+            <a:spAutoFit/>
+          </a:bodyPr>
+          <a:lstStyle/>
+          <a:p>
+            <a:r>
+              <a:rPr sz="3600" b="1"/>
+              <a:t>Demo at a glance</a:t>
+            </a:r>
+          </a:p>
+        </p:txBody>
+      </p:sp>
+      <p:sp>
+        <p:nvSpPr>
+          <p:cNvPr id="3" name="TextBox 2"/>
+          <p:cNvSpPr txBox="1"/>
+          <p:nvPr/>
+        </p:nvSpPr>
+        <p:spPr>
+          <a:xfrm>
+            <a:off x="457200" y="1143000"/>
+            <a:ext cx="10972800" cy="457200"/>
+          </a:xfrm>
+          <a:prstGeom prst="rect">
+            <a:avLst/>
+          </a:prstGeom>
+          <a:noFill/>
+        </p:spPr>
+        <p:txBody>
+          <a:bodyPr wrap="none">
+            <a:spAutoFit/>
+          </a:bodyPr>
+          <a:lstStyle/>
+          <a:p>
+            <a:r>
+              <a:rPr sz="1600" i="1"/>
+              <a:t>Web UI · LangGraph topology + HITL approval gate + Cost telemetry</a:t>
+            </a:r>
+          </a:p>
+        </p:txBody>
+      </p:sp>
+      <p:pic>
+        <p:nvPicPr>
+          <p:cNvPr id="4" name="Picture 3" descr="ui-02-pipeline-complete.png"/>
+          <p:cNvPicPr>
+            <a:picLocks noChangeAspect="1"/>
+          </p:cNvPicPr>
+          <p:nvPr/>
+        </p:nvPicPr>
+        <p:blipFill>
+          <a:blip r:embed="rId2"/>
+          <a:stretch>
+            <a:fillRect/>
+          </a:stretch>
+        </p:blipFill>
+        <p:spPr>
+          <a:xfrm>
+            <a:off x="457200" y="1737360"/>
+            <a:ext cx="10972800" cy="15661519"/>
+          </a:xfrm>
+          <a:prstGeom prst="rect">
+            <a:avLst/>
+          </a:prstGeom>
+        </p:spPr>
+      </p:pic>
+      <p:sp>
+        <p:nvSpPr>
+          <p:cNvPr id="5" name="TextBox 4"/>
+          <p:cNvSpPr txBox="1"/>
+          <p:nvPr/>
+        </p:nvSpPr>
+        <p:spPr>
+          <a:xfrm>
+            <a:off x="457200" y="6400800"/>
+            <a:ext cx="10972800" cy="365760"/>
+          </a:xfrm>
+          <a:prstGeom prst="rect">
+            <a:avLst/>
+          </a:prstGeom>
+          <a:noFill/>
+        </p:spPr>
+        <p:txBody>
+          <a:bodyPr wrap="none">
+            <a:spAutoFit/>
+          </a:bodyPr>
+          <a:lstStyle/>
+          <a:p>
+            <a:r>
+              <a:rPr sz="1000"/>
               <a:t>Ajay Antony  ·  Capgemini Blue Harvest Panel  ·  May 2026</a:t>
             </a:r>
-            <a:endParaRPr lang="en-US" sz="1000" dirty="0"/>
-          </a:p>
-        </p:txBody>
-      </p:sp>
-      <p:sp>
-        <p:nvSpPr>
-          <p:cNvPr id="18" name="Text 16"/>
-          <p:cNvSpPr/>
-          <p:nvPr/>
-        </p:nvSpPr>
-        <p:spPr>
-          <a:xfrm>
-            <a:off x="11338560" y="6492240"/>
-            <a:ext cx="365760" cy="274320"/>
-          </a:xfrm>
-          <a:prstGeom prst="rect">
-            <a:avLst/>
-          </a:prstGeom>
-          <a:noFill/>
-          <a:ln/>
-        </p:spPr>
-        <p:txBody>
-          <a:bodyPr wrap="square" lIns="0" tIns="0" rIns="0" bIns="0" rtlCol="0" anchor="ctr"/>
-          <a:lstStyle/>
-          <a:p>
-            <a:pPr algn="r" indent="0" marL="0">
-              <a:buNone/>
-            </a:pPr>
-            <a:r>
-              <a:rPr lang="en-US" sz="1000" dirty="0">
-                <a:solidFill>
-                  <a:srgbClr val="64748B"/>
-                </a:solidFill>
-                <a:latin typeface="Calibri" pitchFamily="34" charset="0"/>
-                <a:ea typeface="Calibri" pitchFamily="34" charset="-122"/>
-                <a:cs typeface="Calibri" pitchFamily="34" charset="-120"/>
-              </a:rPr>
-              <a:t>19</a:t>
-            </a:r>
-            <a:endParaRPr lang="en-US" sz="1000" dirty="0"/>
           </a:p>
         </p:txBody>
       </p:sp>
@@ -13927,6 +13809,10 @@
             <a:prstDash val="solid"/>
           </a:ln>
         </p:spPr>
+        <p:txBody>
+          <a:bodyPr/>
+          <a:p/>
+        </p:txBody>
       </p:sp>
       <p:sp>
         <p:nvSpPr>
@@ -13991,6 +13877,10 @@
             <a:prstDash val="solid"/>
           </a:ln>
         </p:spPr>
+        <p:txBody>
+          <a:bodyPr/>
+          <a:p/>
+        </p:txBody>
       </p:sp>
       <p:sp>
         <p:nvSpPr>
@@ -14016,6 +13906,10 @@
             <a:prstDash val="solid"/>
           </a:ln>
         </p:spPr>
+        <p:txBody>
+          <a:bodyPr/>
+          <a:p/>
+        </p:txBody>
       </p:sp>
       <p:sp>
         <p:nvSpPr>
@@ -14080,6 +13974,10 @@
             <a:prstDash val="solid"/>
           </a:ln>
         </p:spPr>
+        <p:txBody>
+          <a:bodyPr/>
+          <a:p/>
+        </p:txBody>
       </p:sp>
       <p:sp>
         <p:nvSpPr>
@@ -14144,6 +14042,10 @@
             <a:prstDash val="solid"/>
           </a:ln>
         </p:spPr>
+        <p:txBody>
+          <a:bodyPr/>
+          <a:p/>
+        </p:txBody>
       </p:sp>
       <p:sp>
         <p:nvSpPr>
@@ -14208,6 +14110,10 @@
             <a:prstDash val="solid"/>
           </a:ln>
         </p:spPr>
+        <p:txBody>
+          <a:bodyPr/>
+          <a:p/>
+        </p:txBody>
       </p:sp>
       <p:sp>
         <p:nvSpPr>
@@ -14272,6 +14178,10 @@
             <a:prstDash val="solid"/>
           </a:ln>
         </p:spPr>
+        <p:txBody>
+          <a:bodyPr/>
+          <a:p/>
+        </p:txBody>
       </p:sp>
       <p:sp>
         <p:nvSpPr>
@@ -14336,6 +14246,10 @@
             <a:prstDash val="solid"/>
           </a:ln>
         </p:spPr>
+        <p:txBody>
+          <a:bodyPr/>
+          <a:p/>
+        </p:txBody>
       </p:sp>
       <p:sp>
         <p:nvSpPr>
@@ -14400,6 +14314,10 @@
             <a:prstDash val="solid"/>
           </a:ln>
         </p:spPr>
+        <p:txBody>
+          <a:bodyPr/>
+          <a:p/>
+        </p:txBody>
       </p:sp>
       <p:sp>
         <p:nvSpPr>
@@ -14425,6 +14343,10 @@
             <a:prstDash val="solid"/>
           </a:ln>
         </p:spPr>
+        <p:txBody>
+          <a:bodyPr/>
+          <a:p/>
+        </p:txBody>
       </p:sp>
       <p:sp>
         <p:nvSpPr>
@@ -14489,6 +14411,10 @@
             <a:prstDash val="solid"/>
           </a:ln>
         </p:spPr>
+        <p:txBody>
+          <a:bodyPr/>
+          <a:p/>
+        </p:txBody>
       </p:sp>
       <p:sp>
         <p:nvSpPr>
@@ -14553,6 +14479,10 @@
             <a:prstDash val="solid"/>
           </a:ln>
         </p:spPr>
+        <p:txBody>
+          <a:bodyPr/>
+          <a:p/>
+        </p:txBody>
       </p:sp>
       <p:sp>
         <p:nvSpPr>
@@ -14617,6 +14547,10 @@
             <a:prstDash val="solid"/>
           </a:ln>
         </p:spPr>
+        <p:txBody>
+          <a:bodyPr/>
+          <a:p/>
+        </p:txBody>
       </p:sp>
       <p:sp>
         <p:nvSpPr>
@@ -14681,6 +14615,10 @@
             <a:prstDash val="solid"/>
           </a:ln>
         </p:spPr>
+        <p:txBody>
+          <a:bodyPr/>
+          <a:p/>
+        </p:txBody>
       </p:sp>
       <p:sp>
         <p:nvSpPr>
@@ -14745,6 +14683,10 @@
             <a:prstDash val="solid"/>
           </a:ln>
         </p:spPr>
+        <p:txBody>
+          <a:bodyPr/>
+          <a:p/>
+        </p:txBody>
       </p:sp>
       <p:sp>
         <p:nvSpPr>
@@ -14809,6 +14751,10 @@
             <a:prstDash val="solid"/>
           </a:ln>
         </p:spPr>
+        <p:txBody>
+          <a:bodyPr/>
+          <a:p/>
+        </p:txBody>
       </p:sp>
       <p:sp>
         <p:nvSpPr>
@@ -14873,6 +14819,10 @@
             <a:prstDash val="solid"/>
           </a:ln>
         </p:spPr>
+        <p:txBody>
+          <a:bodyPr/>
+          <a:p/>
+        </p:txBody>
       </p:sp>
       <p:sp>
         <p:nvSpPr>
@@ -14937,6 +14887,10 @@
             <a:prstDash val="solid"/>
           </a:ln>
         </p:spPr>
+        <p:txBody>
+          <a:bodyPr/>
+          <a:p/>
+        </p:txBody>
       </p:sp>
       <p:sp>
         <p:nvSpPr>
@@ -15001,6 +14955,10 @@
             <a:prstDash val="solid"/>
           </a:ln>
         </p:spPr>
+        <p:txBody>
+          <a:bodyPr/>
+          <a:p/>
+        </p:txBody>
       </p:sp>
       <p:sp>
         <p:nvSpPr>
@@ -15026,6 +14984,10 @@
             <a:prstDash val="solid"/>
           </a:ln>
         </p:spPr>
+        <p:txBody>
+          <a:bodyPr/>
+          <a:p/>
+        </p:txBody>
       </p:sp>
       <p:sp>
         <p:nvSpPr>
@@ -15090,6 +15052,10 @@
             <a:prstDash val="solid"/>
           </a:ln>
         </p:spPr>
+        <p:txBody>
+          <a:bodyPr/>
+          <a:p/>
+        </p:txBody>
       </p:sp>
       <p:sp>
         <p:nvSpPr>
@@ -15154,6 +15120,10 @@
             <a:prstDash val="solid"/>
           </a:ln>
         </p:spPr>
+        <p:txBody>
+          <a:bodyPr/>
+          <a:p/>
+        </p:txBody>
       </p:sp>
       <p:sp>
         <p:nvSpPr>
@@ -15218,6 +15188,10 @@
             <a:prstDash val="solid"/>
           </a:ln>
         </p:spPr>
+        <p:txBody>
+          <a:bodyPr/>
+          <a:p/>
+        </p:txBody>
       </p:sp>
       <p:sp>
         <p:nvSpPr>
@@ -15345,6 +15319,621 @@
 </file>
 
 <file path=ppt/slides/slide20.xml><?xml version="1.0" encoding="utf-8"?>
+<p:sld xmlns:a="http://schemas.openxmlformats.org/drawingml/2006/main" xmlns:r="http://schemas.openxmlformats.org/officeDocument/2006/relationships" xmlns:p="http://schemas.openxmlformats.org/presentationml/2006/main">
+  <p:cSld name="Slide 19">
+    <p:bg>
+      <p:bgPr>
+        <a:solidFill>
+          <a:srgbClr val="FFFFFF"/>
+        </a:solidFill>
+      </p:bgPr>
+    </p:bg>
+    <p:spTree>
+      <p:nvGrpSpPr>
+        <p:cNvPr id="1" name=""/>
+        <p:cNvGrpSpPr/>
+        <p:nvPr/>
+      </p:nvGrpSpPr>
+      <p:grpSpPr>
+        <a:xfrm>
+          <a:off x="0" y="0"/>
+          <a:ext cx="0" cy="0"/>
+          <a:chOff x="0" y="0"/>
+          <a:chExt cx="0" cy="0"/>
+        </a:xfrm>
+      </p:grpSpPr>
+      <p:sp>
+        <p:nvSpPr>
+          <p:cNvPr id="2" name="Shape 0"/>
+          <p:cNvSpPr/>
+          <p:nvPr/>
+        </p:nvSpPr>
+        <p:spPr>
+          <a:xfrm>
+            <a:off x="457200" y="502920"/>
+            <a:ext cx="73152" cy="640080"/>
+          </a:xfrm>
+          <a:prstGeom prst="rect">
+            <a:avLst/>
+          </a:prstGeom>
+          <a:solidFill>
+            <a:srgbClr val="0EA5A5"/>
+          </a:solidFill>
+          <a:ln w="12700">
+            <a:solidFill>
+              <a:srgbClr val="0EA5A5"/>
+            </a:solidFill>
+            <a:prstDash val="solid"/>
+          </a:ln>
+        </p:spPr>
+        <p:txBody>
+          <a:bodyPr/>
+          <a:p/>
+        </p:txBody>
+      </p:sp>
+      <p:sp>
+        <p:nvSpPr>
+          <p:cNvPr id="3" name="Text 1"/>
+          <p:cNvSpPr/>
+          <p:nvPr/>
+        </p:nvSpPr>
+        <p:spPr>
+          <a:xfrm>
+            <a:off x="685800" y="457200"/>
+            <a:ext cx="11018520" cy="731520"/>
+          </a:xfrm>
+          <a:prstGeom prst="rect">
+            <a:avLst/>
+          </a:prstGeom>
+          <a:noFill/>
+          <a:ln/>
+        </p:spPr>
+        <p:txBody>
+          <a:bodyPr wrap="square" lIns="0" tIns="0" rIns="0" bIns="0" rtlCol="0" anchor="ctr"/>
+          <a:lstStyle/>
+          <a:p>
+            <a:pPr algn="l" indent="0" marL="0">
+              <a:buNone/>
+            </a:pPr>
+            <a:r>
+              <a:rPr lang="en-US" sz="3000" b="1" dirty="0">
+                <a:solidFill>
+                  <a:srgbClr val="0F172A"/>
+                </a:solidFill>
+                <a:latin typeface="Calibri" pitchFamily="34" charset="0"/>
+                <a:ea typeface="Calibri" pitchFamily="34" charset="-122"/>
+                <a:cs typeface="Calibri" pitchFamily="34" charset="-120"/>
+              </a:rPr>
+              <a:t>Greatest achievement</a:t>
+            </a:r>
+            <a:endParaRPr lang="en-US" sz="3000" dirty="0"/>
+          </a:p>
+        </p:txBody>
+      </p:sp>
+      <p:sp>
+        <p:nvSpPr>
+          <p:cNvPr id="4" name="Shape 2"/>
+          <p:cNvSpPr/>
+          <p:nvPr/>
+        </p:nvSpPr>
+        <p:spPr>
+          <a:xfrm>
+            <a:off x="548640" y="1554480"/>
+            <a:ext cx="5120640" cy="4572000"/>
+          </a:xfrm>
+          <a:prstGeom prst="rect">
+            <a:avLst/>
+          </a:prstGeom>
+          <a:solidFill>
+            <a:srgbClr val="0B1E3F"/>
+          </a:solidFill>
+          <a:ln w="12700">
+            <a:solidFill>
+              <a:srgbClr val="0B1E3F"/>
+            </a:solidFill>
+            <a:prstDash val="solid"/>
+          </a:ln>
+        </p:spPr>
+        <p:txBody>
+          <a:bodyPr/>
+          <a:p/>
+        </p:txBody>
+      </p:sp>
+      <p:sp>
+        <p:nvSpPr>
+          <p:cNvPr id="5" name="Shape 3"/>
+          <p:cNvSpPr/>
+          <p:nvPr/>
+        </p:nvSpPr>
+        <p:spPr>
+          <a:xfrm>
+            <a:off x="548640" y="1554480"/>
+            <a:ext cx="73152" cy="4572000"/>
+          </a:xfrm>
+          <a:prstGeom prst="rect">
+            <a:avLst/>
+          </a:prstGeom>
+          <a:solidFill>
+            <a:srgbClr val="0EA5A5"/>
+          </a:solidFill>
+          <a:ln w="12700">
+            <a:solidFill>
+              <a:srgbClr val="0EA5A5"/>
+            </a:solidFill>
+            <a:prstDash val="solid"/>
+          </a:ln>
+        </p:spPr>
+        <p:txBody>
+          <a:bodyPr/>
+          <a:p/>
+        </p:txBody>
+      </p:sp>
+      <p:sp>
+        <p:nvSpPr>
+          <p:cNvPr id="6" name="Text 4"/>
+          <p:cNvSpPr/>
+          <p:nvPr/>
+        </p:nvSpPr>
+        <p:spPr>
+          <a:xfrm>
+            <a:off x="914400" y="2194560"/>
+            <a:ext cx="4572000" cy="1371600"/>
+          </a:xfrm>
+          <a:prstGeom prst="rect">
+            <a:avLst/>
+          </a:prstGeom>
+          <a:noFill/>
+          <a:ln/>
+        </p:spPr>
+        <p:txBody>
+          <a:bodyPr wrap="square" lIns="0" tIns="0" rIns="0" bIns="0" rtlCol="0" anchor="ctr"/>
+          <a:lstStyle/>
+          <a:p>
+            <a:pPr algn="l" indent="0" marL="0">
+              <a:buNone/>
+            </a:pPr>
+            <a:r>
+              <a:rPr lang="en-US" sz="5400" b="1" dirty="0">
+                <a:solidFill>
+                  <a:srgbClr val="FFFFFF"/>
+                </a:solidFill>
+                <a:latin typeface="Calibri" pitchFamily="34" charset="0"/>
+                <a:ea typeface="Calibri" pitchFamily="34" charset="-122"/>
+                <a:cs typeface="Calibri" pitchFamily="34" charset="-120"/>
+              </a:rPr>
+              <a:t>0  to  Production</a:t>
+            </a:r>
+            <a:endParaRPr lang="en-US" sz="5400" dirty="0"/>
+          </a:p>
+        </p:txBody>
+      </p:sp>
+      <p:sp>
+        <p:nvSpPr>
+          <p:cNvPr id="7" name="Text 5"/>
+          <p:cNvSpPr/>
+          <p:nvPr/>
+        </p:nvSpPr>
+        <p:spPr>
+          <a:xfrm>
+            <a:off x="914400" y="3566160"/>
+            <a:ext cx="4572000" cy="731520"/>
+          </a:xfrm>
+          <a:prstGeom prst="rect">
+            <a:avLst/>
+          </a:prstGeom>
+          <a:noFill/>
+          <a:ln/>
+        </p:spPr>
+        <p:txBody>
+          <a:bodyPr wrap="square" lIns="0" tIns="0" rIns="0" bIns="0" rtlCol="0" anchor="ctr"/>
+          <a:lstStyle/>
+          <a:p>
+            <a:pPr algn="l" indent="0" marL="0">
+              <a:buNone/>
+            </a:pPr>
+            <a:r>
+              <a:rPr lang="en-US" sz="3000" dirty="0">
+                <a:solidFill>
+                  <a:srgbClr val="0EA5A5"/>
+                </a:solidFill>
+                <a:latin typeface="Calibri" pitchFamily="34" charset="0"/>
+                <a:ea typeface="Calibri" pitchFamily="34" charset="-122"/>
+                <a:cs typeface="Calibri" pitchFamily="34" charset="-120"/>
+              </a:rPr>
+              <a:t>in under 2 months</a:t>
+            </a:r>
+            <a:endParaRPr lang="en-US" sz="3000" dirty="0"/>
+          </a:p>
+        </p:txBody>
+      </p:sp>
+      <p:sp>
+        <p:nvSpPr>
+          <p:cNvPr id="8" name="Text 6"/>
+          <p:cNvSpPr/>
+          <p:nvPr/>
+        </p:nvSpPr>
+        <p:spPr>
+          <a:xfrm>
+            <a:off x="914400" y="4389120"/>
+            <a:ext cx="4572000" cy="731520"/>
+          </a:xfrm>
+          <a:prstGeom prst="rect">
+            <a:avLst/>
+          </a:prstGeom>
+          <a:noFill/>
+          <a:ln/>
+        </p:spPr>
+        <p:txBody>
+          <a:bodyPr wrap="square" lIns="0" tIns="0" rIns="0" bIns="0" rtlCol="0" anchor="ctr"/>
+          <a:lstStyle/>
+          <a:p>
+            <a:pPr algn="l" indent="0" marL="0">
+              <a:buNone/>
+            </a:pPr>
+            <a:r>
+              <a:rPr lang="en-US" sz="3000" i="1" dirty="0">
+                <a:solidFill>
+                  <a:srgbClr val="94A3B8"/>
+                </a:solidFill>
+                <a:latin typeface="Calibri" pitchFamily="34" charset="0"/>
+                <a:ea typeface="Calibri" pitchFamily="34" charset="-122"/>
+                <a:cs typeface="Calibri" pitchFamily="34" charset="-120"/>
+              </a:rPr>
+              <a:t>solo</a:t>
+            </a:r>
+            <a:endParaRPr lang="en-US" sz="3000" dirty="0"/>
+          </a:p>
+        </p:txBody>
+      </p:sp>
+      <p:sp>
+        <p:nvSpPr>
+          <p:cNvPr id="9" name="Shape 7"/>
+          <p:cNvSpPr/>
+          <p:nvPr/>
+        </p:nvSpPr>
+        <p:spPr>
+          <a:xfrm>
+            <a:off x="5943600" y="1554480"/>
+            <a:ext cx="5669280" cy="4572000"/>
+          </a:xfrm>
+          <a:prstGeom prst="rect">
+            <a:avLst/>
+          </a:prstGeom>
+          <a:solidFill>
+            <a:srgbClr val="F8FAFC"/>
+          </a:solidFill>
+          <a:ln w="12700">
+            <a:solidFill>
+              <a:srgbClr val="E2E8F0"/>
+            </a:solidFill>
+            <a:prstDash val="solid"/>
+          </a:ln>
+        </p:spPr>
+        <p:txBody>
+          <a:bodyPr/>
+          <a:p/>
+        </p:txBody>
+      </p:sp>
+      <p:sp>
+        <p:nvSpPr>
+          <p:cNvPr id="10" name="Shape 8"/>
+          <p:cNvSpPr/>
+          <p:nvPr/>
+        </p:nvSpPr>
+        <p:spPr>
+          <a:xfrm>
+            <a:off x="5943600" y="1554480"/>
+            <a:ext cx="73152" cy="4572000"/>
+          </a:xfrm>
+          <a:prstGeom prst="rect">
+            <a:avLst/>
+          </a:prstGeom>
+          <a:solidFill>
+            <a:srgbClr val="0EA5A5"/>
+          </a:solidFill>
+          <a:ln w="12700">
+            <a:solidFill>
+              <a:srgbClr val="0EA5A5"/>
+            </a:solidFill>
+            <a:prstDash val="solid"/>
+          </a:ln>
+        </p:spPr>
+        <p:txBody>
+          <a:bodyPr/>
+          <a:p/>
+        </p:txBody>
+      </p:sp>
+      <p:sp>
+        <p:nvSpPr>
+          <p:cNvPr id="11" name="Shape 9"/>
+          <p:cNvSpPr/>
+          <p:nvPr/>
+        </p:nvSpPr>
+        <p:spPr>
+          <a:xfrm>
+            <a:off x="6236208" y="2207895"/>
+            <a:ext cx="109728" cy="109728"/>
+          </a:xfrm>
+          <a:prstGeom prst="ellipse">
+            <a:avLst/>
+          </a:prstGeom>
+          <a:solidFill>
+            <a:srgbClr val="0EA5A5"/>
+          </a:solidFill>
+          <a:ln w="12700">
+            <a:solidFill>
+              <a:srgbClr val="0EA5A5"/>
+            </a:solidFill>
+            <a:prstDash val="solid"/>
+          </a:ln>
+        </p:spPr>
+        <p:txBody>
+          <a:bodyPr/>
+          <a:p/>
+        </p:txBody>
+      </p:sp>
+      <p:sp>
+        <p:nvSpPr>
+          <p:cNvPr id="12" name="Text 10"/>
+          <p:cNvSpPr/>
+          <p:nvPr/>
+        </p:nvSpPr>
+        <p:spPr>
+          <a:xfrm>
+            <a:off x="6473952" y="2103120"/>
+            <a:ext cx="4956048" cy="1143000"/>
+          </a:xfrm>
+          <a:prstGeom prst="rect">
+            <a:avLst/>
+          </a:prstGeom>
+          <a:noFill/>
+          <a:ln/>
+        </p:spPr>
+        <p:txBody>
+          <a:bodyPr wrap="square" lIns="0" tIns="0" rIns="0" bIns="0" rtlCol="0" anchor="t"/>
+          <a:lstStyle/>
+          <a:p>
+            <a:pPr algn="l" indent="0" marL="0">
+              <a:buNone/>
+            </a:pPr>
+            <a:r>
+              <a:rPr lang="en-US" sz="1500" dirty="0">
+                <a:solidFill>
+                  <a:srgbClr val="0F172A"/>
+                </a:solidFill>
+                <a:latin typeface="Calibri" pitchFamily="34" charset="0"/>
+                <a:ea typeface="Calibri" pitchFamily="34" charset="-122"/>
+                <a:cs typeface="Calibri" pitchFamily="34" charset="-120"/>
+              </a:rPr>
+              <a:t>Scope: Platform that would normally be a squad's quarter</a:t>
+            </a:r>
+            <a:endParaRPr lang="en-US" sz="1500" dirty="0"/>
+          </a:p>
+        </p:txBody>
+      </p:sp>
+      <p:sp>
+        <p:nvSpPr>
+          <p:cNvPr id="13" name="Shape 11"/>
+          <p:cNvSpPr/>
+          <p:nvPr/>
+        </p:nvSpPr>
+        <p:spPr>
+          <a:xfrm>
+            <a:off x="6236208" y="3350895"/>
+            <a:ext cx="109728" cy="109728"/>
+          </a:xfrm>
+          <a:prstGeom prst="ellipse">
+            <a:avLst/>
+          </a:prstGeom>
+          <a:solidFill>
+            <a:srgbClr val="0EA5A5"/>
+          </a:solidFill>
+          <a:ln w="12700">
+            <a:solidFill>
+              <a:srgbClr val="0EA5A5"/>
+            </a:solidFill>
+            <a:prstDash val="solid"/>
+          </a:ln>
+        </p:spPr>
+        <p:txBody>
+          <a:bodyPr/>
+          <a:p/>
+        </p:txBody>
+      </p:sp>
+      <p:sp>
+        <p:nvSpPr>
+          <p:cNvPr id="14" name="Text 12"/>
+          <p:cNvSpPr/>
+          <p:nvPr/>
+        </p:nvSpPr>
+        <p:spPr>
+          <a:xfrm>
+            <a:off x="6473952" y="3246120"/>
+            <a:ext cx="4956048" cy="1143000"/>
+          </a:xfrm>
+          <a:prstGeom prst="rect">
+            <a:avLst/>
+          </a:prstGeom>
+          <a:noFill/>
+          <a:ln/>
+        </p:spPr>
+        <p:txBody>
+          <a:bodyPr wrap="square" lIns="0" tIns="0" rIns="0" bIns="0" rtlCol="0" anchor="t"/>
+          <a:lstStyle/>
+          <a:p>
+            <a:pPr algn="l" indent="0" marL="0">
+              <a:buNone/>
+            </a:pPr>
+            <a:r>
+              <a:rPr lang="en-US" sz="1500" dirty="0">
+                <a:solidFill>
+                  <a:srgbClr val="0F172A"/>
+                </a:solidFill>
+                <a:latin typeface="Calibri" pitchFamily="34" charset="0"/>
+                <a:ea typeface="Calibri" pitchFamily="34" charset="-122"/>
+                <a:cs typeface="Calibri" pitchFamily="34" charset="-120"/>
+              </a:rPr>
+              <a:t>Constraint: Solo engineering, new business domain, two-month window</a:t>
+            </a:r>
+            <a:endParaRPr lang="en-US" sz="1500" dirty="0"/>
+          </a:p>
+        </p:txBody>
+      </p:sp>
+      <p:sp>
+        <p:nvSpPr>
+          <p:cNvPr id="15" name="Shape 13"/>
+          <p:cNvSpPr/>
+          <p:nvPr/>
+        </p:nvSpPr>
+        <p:spPr>
+          <a:xfrm>
+            <a:off x="6236208" y="4493895"/>
+            <a:ext cx="109728" cy="109728"/>
+          </a:xfrm>
+          <a:prstGeom prst="ellipse">
+            <a:avLst/>
+          </a:prstGeom>
+          <a:solidFill>
+            <a:srgbClr val="0EA5A5"/>
+          </a:solidFill>
+          <a:ln w="12700">
+            <a:solidFill>
+              <a:srgbClr val="0EA5A5"/>
+            </a:solidFill>
+            <a:prstDash val="solid"/>
+          </a:ln>
+        </p:spPr>
+        <p:txBody>
+          <a:bodyPr/>
+          <a:p/>
+        </p:txBody>
+      </p:sp>
+      <p:sp>
+        <p:nvSpPr>
+          <p:cNvPr id="16" name="Text 14"/>
+          <p:cNvSpPr/>
+          <p:nvPr/>
+        </p:nvSpPr>
+        <p:spPr>
+          <a:xfrm>
+            <a:off x="6473952" y="4389120"/>
+            <a:ext cx="4956048" cy="1143000"/>
+          </a:xfrm>
+          <a:prstGeom prst="rect">
+            <a:avLst/>
+          </a:prstGeom>
+          <a:noFill/>
+          <a:ln/>
+        </p:spPr>
+        <p:txBody>
+          <a:bodyPr wrap="square" lIns="0" tIns="0" rIns="0" bIns="0" rtlCol="0" anchor="t"/>
+          <a:lstStyle/>
+          <a:p>
+            <a:pPr algn="l" indent="0" marL="0">
+              <a:buNone/>
+            </a:pPr>
+            <a:r>
+              <a:rPr lang="en-US" sz="1500" dirty="0">
+                <a:solidFill>
+                  <a:srgbClr val="0F172A"/>
+                </a:solidFill>
+                <a:latin typeface="Calibri" pitchFamily="34" charset="0"/>
+                <a:ea typeface="Calibri" pitchFamily="34" charset="-122"/>
+                <a:cs typeface="Calibri" pitchFamily="34" charset="-120"/>
+              </a:rPr>
+              <a:t>Result: Production live; written recognition from client and Infosys leadership</a:t>
+            </a:r>
+            <a:endParaRPr lang="en-US" sz="1500" dirty="0"/>
+          </a:p>
+        </p:txBody>
+      </p:sp>
+      <p:sp>
+        <p:nvSpPr>
+          <p:cNvPr id="17" name="Text 15"/>
+          <p:cNvSpPr/>
+          <p:nvPr/>
+        </p:nvSpPr>
+        <p:spPr>
+          <a:xfrm>
+            <a:off x="457200" y="6492240"/>
+            <a:ext cx="10789920" cy="274320"/>
+          </a:xfrm>
+          <a:prstGeom prst="rect">
+            <a:avLst/>
+          </a:prstGeom>
+          <a:noFill/>
+          <a:ln/>
+        </p:spPr>
+        <p:txBody>
+          <a:bodyPr wrap="square" lIns="0" tIns="0" rIns="0" bIns="0" rtlCol="0" anchor="ctr"/>
+          <a:lstStyle/>
+          <a:p>
+            <a:pPr algn="l" indent="0" marL="0">
+              <a:buNone/>
+            </a:pPr>
+            <a:r>
+              <a:rPr lang="en-US" sz="1000" dirty="0">
+                <a:solidFill>
+                  <a:srgbClr val="64748B"/>
+                </a:solidFill>
+                <a:latin typeface="Calibri" pitchFamily="34" charset="0"/>
+                <a:ea typeface="Calibri" pitchFamily="34" charset="-122"/>
+                <a:cs typeface="Calibri" pitchFamily="34" charset="-120"/>
+              </a:rPr>
+              <a:t>Ajay Antony  ·  Capgemini Blue Harvest Panel  ·  May 2026</a:t>
+            </a:r>
+            <a:endParaRPr lang="en-US" sz="1000" dirty="0"/>
+          </a:p>
+        </p:txBody>
+      </p:sp>
+      <p:sp>
+        <p:nvSpPr>
+          <p:cNvPr id="18" name="Text 16"/>
+          <p:cNvSpPr/>
+          <p:nvPr/>
+        </p:nvSpPr>
+        <p:spPr>
+          <a:xfrm>
+            <a:off x="11338560" y="6492240"/>
+            <a:ext cx="365760" cy="274320"/>
+          </a:xfrm>
+          <a:prstGeom prst="rect">
+            <a:avLst/>
+          </a:prstGeom>
+          <a:noFill/>
+          <a:ln/>
+        </p:spPr>
+        <p:txBody>
+          <a:bodyPr wrap="square" lIns="0" tIns="0" rIns="0" bIns="0" rtlCol="0" anchor="ctr"/>
+          <a:lstStyle/>
+          <a:p>
+            <a:pPr algn="r" indent="0" marL="0">
+              <a:buNone/>
+            </a:pPr>
+            <a:r>
+              <a:rPr lang="en-US" sz="1000" dirty="0">
+                <a:solidFill>
+                  <a:srgbClr val="64748B"/>
+                </a:solidFill>
+                <a:latin typeface="Calibri" pitchFamily="34" charset="0"/>
+                <a:ea typeface="Calibri" pitchFamily="34" charset="-122"/>
+                <a:cs typeface="Calibri" pitchFamily="34" charset="-120"/>
+              </a:rPr>
+              <a:t>19</a:t>
+            </a:r>
+            <a:endParaRPr lang="en-US" sz="1000" dirty="0"/>
+          </a:p>
+        </p:txBody>
+      </p:sp>
+    </p:spTree>
+  </p:cSld>
+  <p:clrMapOvr>
+    <a:masterClrMapping/>
+  </p:clrMapOvr>
+</p:sld>
+</file>
+
+<file path=ppt/slides/slide21.xml><?xml version="1.0" encoding="utf-8"?>
 <p:sld xmlns:a="http://schemas.openxmlformats.org/drawingml/2006/main" xmlns:r="http://schemas.openxmlformats.org/officeDocument/2006/relationships" xmlns:p="http://schemas.openxmlformats.org/presentationml/2006/main">
   <p:cSld name="Slide 20">
     <p:bg>
@@ -15392,6 +15981,10 @@
             <a:prstDash val="solid"/>
           </a:ln>
         </p:spPr>
+        <p:txBody>
+          <a:bodyPr/>
+          <a:p/>
+        </p:txBody>
       </p:sp>
       <p:sp>
         <p:nvSpPr>
@@ -15456,6 +16049,10 @@
             <a:prstDash val="solid"/>
           </a:ln>
         </p:spPr>
+        <p:txBody>
+          <a:bodyPr/>
+          <a:p/>
+        </p:txBody>
       </p:sp>
       <p:sp>
         <p:nvSpPr>
@@ -15481,6 +16078,10 @@
             <a:prstDash val="solid"/>
           </a:ln>
         </p:spPr>
+        <p:txBody>
+          <a:bodyPr/>
+          <a:p/>
+        </p:txBody>
       </p:sp>
       <p:sp>
         <p:nvSpPr>
@@ -15545,6 +16146,10 @@
             <a:prstDash val="solid"/>
           </a:ln>
         </p:spPr>
+        <p:txBody>
+          <a:bodyPr/>
+          <a:p/>
+        </p:txBody>
       </p:sp>
       <p:sp>
         <p:nvSpPr>
@@ -15609,6 +16214,10 @@
             <a:prstDash val="solid"/>
           </a:ln>
         </p:spPr>
+        <p:txBody>
+          <a:bodyPr/>
+          <a:p/>
+        </p:txBody>
       </p:sp>
       <p:sp>
         <p:nvSpPr>
@@ -15673,6 +16282,10 @@
             <a:prstDash val="solid"/>
           </a:ln>
         </p:spPr>
+        <p:txBody>
+          <a:bodyPr/>
+          <a:p/>
+        </p:txBody>
       </p:sp>
       <p:sp>
         <p:nvSpPr>
@@ -15737,6 +16350,10 @@
             <a:prstDash val="solid"/>
           </a:ln>
         </p:spPr>
+        <p:txBody>
+          <a:bodyPr/>
+          <a:p/>
+        </p:txBody>
       </p:sp>
       <p:sp>
         <p:nvSpPr>
@@ -15762,6 +16379,10 @@
             <a:prstDash val="solid"/>
           </a:ln>
         </p:spPr>
+        <p:txBody>
+          <a:bodyPr/>
+          <a:p/>
+        </p:txBody>
       </p:sp>
       <p:sp>
         <p:nvSpPr>
@@ -15826,6 +16447,10 @@
             <a:prstDash val="solid"/>
           </a:ln>
         </p:spPr>
+        <p:txBody>
+          <a:bodyPr/>
+          <a:p/>
+        </p:txBody>
       </p:sp>
       <p:sp>
         <p:nvSpPr>
@@ -15890,6 +16515,10 @@
             <a:prstDash val="solid"/>
           </a:ln>
         </p:spPr>
+        <p:txBody>
+          <a:bodyPr/>
+          <a:p/>
+        </p:txBody>
       </p:sp>
       <p:sp>
         <p:nvSpPr>
@@ -15954,6 +16583,10 @@
             <a:prstDash val="solid"/>
           </a:ln>
         </p:spPr>
+        <p:txBody>
+          <a:bodyPr/>
+          <a:p/>
+        </p:txBody>
       </p:sp>
       <p:sp>
         <p:nvSpPr>
@@ -16018,6 +16651,10 @@
             <a:prstDash val="solid"/>
           </a:ln>
         </p:spPr>
+        <p:txBody>
+          <a:bodyPr/>
+          <a:p/>
+        </p:txBody>
       </p:sp>
       <p:sp>
         <p:nvSpPr>
@@ -16144,7 +16781,7 @@
 </p:sld>
 </file>
 
-<file path=ppt/slides/slide21.xml><?xml version="1.0" encoding="utf-8"?>
+<file path=ppt/slides/slide22.xml><?xml version="1.0" encoding="utf-8"?>
 <p:sld xmlns:a="http://schemas.openxmlformats.org/drawingml/2006/main" xmlns:r="http://schemas.openxmlformats.org/officeDocument/2006/relationships" xmlns:p="http://schemas.openxmlformats.org/presentationml/2006/main">
   <p:cSld name="Slide 21">
     <p:bg>
@@ -16192,6 +16829,10 @@
             <a:prstDash val="solid"/>
           </a:ln>
         </p:spPr>
+        <p:txBody>
+          <a:bodyPr/>
+          <a:p/>
+        </p:txBody>
       </p:sp>
       <p:sp>
         <p:nvSpPr>
@@ -16304,7 +16945,7 @@
                 <a:ea typeface="Calibri" pitchFamily="34" charset="-122"/>
                 <a:cs typeface="Calibri" pitchFamily="34" charset="-120"/>
               </a:rPr>
-              <a:t>Ajay Antony  ·  ajaybelgium724@gmail.com  ·  +32 489 956 432</a:t>
+              <a:t>Ajay Antony  ·  ajaybelgium724@gmail.com</a:t>
             </a:r>
             <a:endParaRPr lang="en-US" sz="1600" dirty="0"/>
           </a:p>
@@ -16385,135 +17026,6 @@
               <a:t>21</a:t>
             </a:r>
             <a:endParaRPr lang="en-US" sz="1000" dirty="0"/>
-          </a:p>
-        </p:txBody>
-      </p:sp>
-    </p:spTree>
-  </p:cSld>
-  <p:clrMapOvr>
-    <a:masterClrMapping/>
-  </p:clrMapOvr>
-</p:sld>
-</file>
-
-<file path=ppt/slides/slide22.xml><?xml version="1.0" encoding="utf-8"?>
-<p:sld xmlns:a="http://schemas.openxmlformats.org/drawingml/2006/main" xmlns:p="http://schemas.openxmlformats.org/presentationml/2006/main" xmlns:r="http://schemas.openxmlformats.org/officeDocument/2006/relationships">
-  <p:cSld>
-    <p:spTree>
-      <p:nvGrpSpPr>
-        <p:cNvPr id="1" name=""/>
-        <p:cNvGrpSpPr/>
-        <p:nvPr/>
-      </p:nvGrpSpPr>
-      <p:grpSpPr/>
-      <p:sp>
-        <p:nvSpPr>
-          <p:cNvPr id="2" name="TextBox 1"/>
-          <p:cNvSpPr txBox="1"/>
-          <p:nvPr/>
-        </p:nvSpPr>
-        <p:spPr>
-          <a:xfrm>
-            <a:off x="457200" y="365760"/>
-            <a:ext cx="10972800" cy="822960"/>
-          </a:xfrm>
-          <a:prstGeom prst="rect">
-            <a:avLst/>
-          </a:prstGeom>
-          <a:noFill/>
-        </p:spPr>
-        <p:txBody>
-          <a:bodyPr wrap="none">
-            <a:spAutoFit/>
-          </a:bodyPr>
-          <a:lstStyle/>
-          <a:p>
-            <a:r>
-              <a:rPr sz="3600" b="1"/>
-              <a:t>Demo at a glance</a:t>
-            </a:r>
-          </a:p>
-        </p:txBody>
-      </p:sp>
-      <p:sp>
-        <p:nvSpPr>
-          <p:cNvPr id="3" name="TextBox 2"/>
-          <p:cNvSpPr txBox="1"/>
-          <p:nvPr/>
-        </p:nvSpPr>
-        <p:spPr>
-          <a:xfrm>
-            <a:off x="457200" y="1143000"/>
-            <a:ext cx="10972800" cy="457200"/>
-          </a:xfrm>
-          <a:prstGeom prst="rect">
-            <a:avLst/>
-          </a:prstGeom>
-          <a:noFill/>
-        </p:spPr>
-        <p:txBody>
-          <a:bodyPr wrap="none">
-            <a:spAutoFit/>
-          </a:bodyPr>
-          <a:lstStyle/>
-          <a:p>
-            <a:r>
-              <a:rPr sz="1600" i="1"/>
-              <a:t>Web UI · LangGraph topology + HITL approval gate + Cost telemetry</a:t>
-            </a:r>
-          </a:p>
-        </p:txBody>
-      </p:sp>
-      <p:pic>
-        <p:nvPicPr>
-          <p:cNvPr id="4" name="Picture 3" descr="ui-02-pipeline-complete.png"/>
-          <p:cNvPicPr>
-            <a:picLocks noChangeAspect="1"/>
-          </p:cNvPicPr>
-          <p:nvPr/>
-        </p:nvPicPr>
-        <p:blipFill>
-          <a:blip r:embed="rId2"/>
-          <a:stretch>
-            <a:fillRect/>
-          </a:stretch>
-        </p:blipFill>
-        <p:spPr>
-          <a:xfrm>
-            <a:off x="457200" y="1737360"/>
-            <a:ext cx="10972800" cy="15661519"/>
-          </a:xfrm>
-          <a:prstGeom prst="rect">
-            <a:avLst/>
-          </a:prstGeom>
-        </p:spPr>
-      </p:pic>
-      <p:sp>
-        <p:nvSpPr>
-          <p:cNvPr id="5" name="TextBox 4"/>
-          <p:cNvSpPr txBox="1"/>
-          <p:nvPr/>
-        </p:nvSpPr>
-        <p:spPr>
-          <a:xfrm>
-            <a:off x="457200" y="6400800"/>
-            <a:ext cx="10972800" cy="365760"/>
-          </a:xfrm>
-          <a:prstGeom prst="rect">
-            <a:avLst/>
-          </a:prstGeom>
-          <a:noFill/>
-        </p:spPr>
-        <p:txBody>
-          <a:bodyPr wrap="none">
-            <a:spAutoFit/>
-          </a:bodyPr>
-          <a:lstStyle/>
-          <a:p>
-            <a:r>
-              <a:rPr sz="1000"/>
-              <a:t>Ajay Antony  ·  Capgemini Blue Harvest Panel  ·  May 2026</a:t>
-            </a:r>
           </a:p>
         </p:txBody>
       </p:sp>
@@ -16573,6 +17085,10 @@
             <a:prstDash val="solid"/>
           </a:ln>
         </p:spPr>
+        <p:txBody>
+          <a:bodyPr/>
+          <a:p/>
+        </p:txBody>
       </p:sp>
       <p:sp>
         <p:nvSpPr>
@@ -16637,6 +17153,10 @@
             <a:prstDash val="solid"/>
           </a:ln>
         </p:spPr>
+        <p:txBody>
+          <a:bodyPr/>
+          <a:p/>
+        </p:txBody>
       </p:sp>
       <p:sp>
         <p:nvSpPr>
@@ -16662,6 +17182,10 @@
             <a:prstDash val="solid"/>
           </a:ln>
         </p:spPr>
+        <p:txBody>
+          <a:bodyPr/>
+          <a:p/>
+        </p:txBody>
       </p:sp>
       <p:sp>
         <p:nvSpPr>
@@ -16726,6 +17250,10 @@
             <a:prstDash val="solid"/>
           </a:ln>
         </p:spPr>
+        <p:txBody>
+          <a:bodyPr/>
+          <a:p/>
+        </p:txBody>
       </p:sp>
       <p:sp>
         <p:nvSpPr>
@@ -16790,6 +17318,10 @@
             <a:prstDash val="solid"/>
           </a:ln>
         </p:spPr>
+        <p:txBody>
+          <a:bodyPr/>
+          <a:p/>
+        </p:txBody>
       </p:sp>
       <p:sp>
         <p:nvSpPr>
@@ -16854,6 +17386,10 @@
             <a:prstDash val="solid"/>
           </a:ln>
         </p:spPr>
+        <p:txBody>
+          <a:bodyPr/>
+          <a:p/>
+        </p:txBody>
       </p:sp>
       <p:sp>
         <p:nvSpPr>
@@ -16918,6 +17454,10 @@
             <a:prstDash val="solid"/>
           </a:ln>
         </p:spPr>
+        <p:txBody>
+          <a:bodyPr/>
+          <a:p/>
+        </p:txBody>
       </p:sp>
       <p:sp>
         <p:nvSpPr>
@@ -16982,6 +17522,10 @@
             <a:prstDash val="solid"/>
           </a:ln>
         </p:spPr>
+        <p:txBody>
+          <a:bodyPr/>
+          <a:p/>
+        </p:txBody>
       </p:sp>
       <p:sp>
         <p:nvSpPr>
@@ -17007,6 +17551,10 @@
             <a:prstDash val="solid"/>
           </a:ln>
         </p:spPr>
+        <p:txBody>
+          <a:bodyPr/>
+          <a:p/>
+        </p:txBody>
       </p:sp>
       <p:sp>
         <p:nvSpPr>
@@ -17071,6 +17619,10 @@
             <a:prstDash val="solid"/>
           </a:ln>
         </p:spPr>
+        <p:txBody>
+          <a:bodyPr/>
+          <a:p/>
+        </p:txBody>
       </p:sp>
       <p:sp>
         <p:nvSpPr>
@@ -17135,6 +17687,10 @@
             <a:prstDash val="solid"/>
           </a:ln>
         </p:spPr>
+        <p:txBody>
+          <a:bodyPr/>
+          <a:p/>
+        </p:txBody>
       </p:sp>
       <p:sp>
         <p:nvSpPr>
@@ -17199,6 +17755,10 @@
             <a:prstDash val="solid"/>
           </a:ln>
         </p:spPr>
+        <p:txBody>
+          <a:bodyPr/>
+          <a:p/>
+        </p:txBody>
       </p:sp>
       <p:sp>
         <p:nvSpPr>
@@ -17373,6 +17933,10 @@
             <a:prstDash val="solid"/>
           </a:ln>
         </p:spPr>
+        <p:txBody>
+          <a:bodyPr/>
+          <a:p/>
+        </p:txBody>
       </p:sp>
       <p:sp>
         <p:nvSpPr>
@@ -17437,6 +18001,10 @@
             <a:prstDash val="solid"/>
           </a:ln>
         </p:spPr>
+        <p:txBody>
+          <a:bodyPr/>
+          <a:p/>
+        </p:txBody>
       </p:sp>
       <p:sp>
         <p:nvSpPr>
@@ -17462,6 +18030,10 @@
             <a:prstDash val="solid"/>
           </a:ln>
         </p:spPr>
+        <p:txBody>
+          <a:bodyPr/>
+          <a:p/>
+        </p:txBody>
       </p:sp>
       <p:sp>
         <p:nvSpPr>
@@ -17565,6 +18137,10 @@
             <a:prstDash val="solid"/>
           </a:ln>
         </p:spPr>
+        <p:txBody>
+          <a:bodyPr/>
+          <a:p/>
+        </p:txBody>
       </p:sp>
       <p:sp>
         <p:nvSpPr>
@@ -17590,6 +18166,10 @@
             <a:prstDash val="solid"/>
           </a:ln>
         </p:spPr>
+        <p:txBody>
+          <a:bodyPr/>
+          <a:p/>
+        </p:txBody>
       </p:sp>
       <p:sp>
         <p:nvSpPr>
@@ -17693,6 +18273,10 @@
             <a:prstDash val="solid"/>
           </a:ln>
         </p:spPr>
+        <p:txBody>
+          <a:bodyPr/>
+          <a:p/>
+        </p:txBody>
       </p:sp>
       <p:sp>
         <p:nvSpPr>
@@ -17718,6 +18302,10 @@
             <a:prstDash val="solid"/>
           </a:ln>
         </p:spPr>
+        <p:txBody>
+          <a:bodyPr/>
+          <a:p/>
+        </p:txBody>
       </p:sp>
       <p:sp>
         <p:nvSpPr>
@@ -17821,6 +18409,10 @@
             <a:prstDash val="solid"/>
           </a:ln>
         </p:spPr>
+        <p:txBody>
+          <a:bodyPr/>
+          <a:p/>
+        </p:txBody>
       </p:sp>
       <p:sp>
         <p:nvSpPr>
@@ -17846,6 +18438,10 @@
             <a:prstDash val="solid"/>
           </a:ln>
         </p:spPr>
+        <p:txBody>
+          <a:bodyPr/>
+          <a:p/>
+        </p:txBody>
       </p:sp>
       <p:sp>
         <p:nvSpPr>
@@ -18059,6 +18655,10 @@
             <a:prstDash val="solid"/>
           </a:ln>
         </p:spPr>
+        <p:txBody>
+          <a:bodyPr/>
+          <a:p/>
+        </p:txBody>
       </p:sp>
       <p:sp>
         <p:nvSpPr>
@@ -18123,6 +18723,10 @@
             <a:prstDash val="solid"/>
           </a:ln>
         </p:spPr>
+        <p:txBody>
+          <a:bodyPr/>
+          <a:p/>
+        </p:txBody>
       </p:sp>
       <p:sp>
         <p:nvSpPr>
@@ -18186,6 +18790,10 @@
             <a:tailEnd type="triangle"/>
           </a:ln>
         </p:spPr>
+        <p:txBody>
+          <a:bodyPr/>
+          <a:p/>
+        </p:txBody>
       </p:sp>
       <p:sp>
         <p:nvSpPr>
@@ -18211,6 +18819,10 @@
             <a:prstDash val="solid"/>
           </a:ln>
         </p:spPr>
+        <p:txBody>
+          <a:bodyPr/>
+          <a:p/>
+        </p:txBody>
       </p:sp>
       <p:sp>
         <p:nvSpPr>
@@ -18274,6 +18886,10 @@
             <a:tailEnd type="triangle"/>
           </a:ln>
         </p:spPr>
+        <p:txBody>
+          <a:bodyPr/>
+          <a:p/>
+        </p:txBody>
       </p:sp>
       <p:sp>
         <p:nvSpPr>
@@ -18299,6 +18915,10 @@
             <a:prstDash val="solid"/>
           </a:ln>
         </p:spPr>
+        <p:txBody>
+          <a:bodyPr/>
+          <a:p/>
+        </p:txBody>
       </p:sp>
       <p:sp>
         <p:nvSpPr>
@@ -18363,6 +18983,10 @@
             <a:prstDash val="solid"/>
           </a:ln>
         </p:spPr>
+        <p:txBody>
+          <a:bodyPr/>
+          <a:p/>
+        </p:txBody>
       </p:sp>
       <p:sp>
         <p:nvSpPr>
@@ -18466,6 +19090,10 @@
             <a:prstDash val="solid"/>
           </a:ln>
         </p:spPr>
+        <p:txBody>
+          <a:bodyPr/>
+          <a:p/>
+        </p:txBody>
       </p:sp>
       <p:sp>
         <p:nvSpPr>
@@ -18569,6 +19197,10 @@
             <a:prstDash val="solid"/>
           </a:ln>
         </p:spPr>
+        <p:txBody>
+          <a:bodyPr/>
+          <a:p/>
+        </p:txBody>
       </p:sp>
       <p:sp>
         <p:nvSpPr>
@@ -18671,6 +19303,10 @@
             <a:tailEnd type="triangle"/>
           </a:ln>
         </p:spPr>
+        <p:txBody>
+          <a:bodyPr/>
+          <a:p/>
+        </p:txBody>
       </p:sp>
       <p:sp>
         <p:nvSpPr>
@@ -18695,6 +19331,10 @@
             <a:tailEnd type="triangle"/>
           </a:ln>
         </p:spPr>
+        <p:txBody>
+          <a:bodyPr/>
+          <a:p/>
+        </p:txBody>
       </p:sp>
       <p:sp>
         <p:nvSpPr>
@@ -18719,6 +19359,10 @@
             <a:tailEnd type="triangle"/>
           </a:ln>
         </p:spPr>
+        <p:txBody>
+          <a:bodyPr/>
+          <a:p/>
+        </p:txBody>
       </p:sp>
       <p:sp>
         <p:nvSpPr>
@@ -18744,6 +19388,10 @@
             <a:prstDash val="solid"/>
           </a:ln>
         </p:spPr>
+        <p:txBody>
+          <a:bodyPr/>
+          <a:p/>
+        </p:txBody>
       </p:sp>
       <p:sp>
         <p:nvSpPr>
@@ -18847,6 +19495,10 @@
             <a:prstDash val="solid"/>
           </a:ln>
         </p:spPr>
+        <p:txBody>
+          <a:bodyPr/>
+          <a:p/>
+        </p:txBody>
       </p:sp>
       <p:sp>
         <p:nvSpPr>
@@ -18950,6 +19602,10 @@
             <a:prstDash val="solid"/>
           </a:ln>
         </p:spPr>
+        <p:txBody>
+          <a:bodyPr/>
+          <a:p/>
+        </p:txBody>
       </p:sp>
       <p:sp>
         <p:nvSpPr>
@@ -19052,6 +19708,10 @@
             <a:tailEnd type="triangle"/>
           </a:ln>
         </p:spPr>
+        <p:txBody>
+          <a:bodyPr/>
+          <a:p/>
+        </p:txBody>
       </p:sp>
       <p:sp>
         <p:nvSpPr>
@@ -19076,6 +19736,10 @@
             <a:tailEnd type="triangle"/>
           </a:ln>
         </p:spPr>
+        <p:txBody>
+          <a:bodyPr/>
+          <a:p/>
+        </p:txBody>
       </p:sp>
       <p:sp>
         <p:nvSpPr>
@@ -19100,6 +19764,10 @@
             <a:tailEnd type="triangle"/>
           </a:ln>
         </p:spPr>
+        <p:txBody>
+          <a:bodyPr/>
+          <a:p/>
+        </p:txBody>
       </p:sp>
       <p:sp>
         <p:nvSpPr>
@@ -19163,6 +19831,10 @@
             <a:tailEnd type="triangle"/>
           </a:ln>
         </p:spPr>
+        <p:txBody>
+          <a:bodyPr/>
+          <a:p/>
+        </p:txBody>
       </p:sp>
       <p:sp>
         <p:nvSpPr>
@@ -19227,6 +19899,10 @@
             <a:prstDash val="solid"/>
           </a:ln>
         </p:spPr>
+        <p:txBody>
+          <a:bodyPr/>
+          <a:p/>
+        </p:txBody>
       </p:sp>
       <p:sp>
         <p:nvSpPr>
@@ -19330,6 +20006,10 @@
             <a:prstDash val="solid"/>
           </a:ln>
         </p:spPr>
+        <p:txBody>
+          <a:bodyPr/>
+          <a:p/>
+        </p:txBody>
       </p:sp>
       <p:sp>
         <p:nvSpPr>
@@ -19543,6 +20223,10 @@
             <a:prstDash val="solid"/>
           </a:ln>
         </p:spPr>
+        <p:txBody>
+          <a:bodyPr/>
+          <a:p/>
+        </p:txBody>
       </p:sp>
       <p:sp>
         <p:nvSpPr>
@@ -19607,6 +20291,10 @@
             <a:prstDash val="solid"/>
           </a:ln>
         </p:spPr>
+        <p:txBody>
+          <a:bodyPr/>
+          <a:p/>
+        </p:txBody>
       </p:sp>
       <p:sp>
         <p:nvSpPr>
@@ -19632,6 +20320,10 @@
             <a:prstDash val="solid"/>
           </a:ln>
         </p:spPr>
+        <p:txBody>
+          <a:bodyPr/>
+          <a:p/>
+        </p:txBody>
       </p:sp>
       <p:sp>
         <p:nvSpPr>
@@ -19852,6 +20544,10 @@
             <a:prstDash val="solid"/>
           </a:ln>
         </p:spPr>
+        <p:txBody>
+          <a:bodyPr/>
+          <a:p/>
+        </p:txBody>
       </p:sp>
       <p:sp>
         <p:nvSpPr>
@@ -19877,6 +20573,10 @@
             <a:prstDash val="solid"/>
           </a:ln>
         </p:spPr>
+        <p:txBody>
+          <a:bodyPr/>
+          <a:p/>
+        </p:txBody>
       </p:sp>
       <p:sp>
         <p:nvSpPr>
@@ -20097,6 +20797,10 @@
             <a:prstDash val="solid"/>
           </a:ln>
         </p:spPr>
+        <p:txBody>
+          <a:bodyPr/>
+          <a:p/>
+        </p:txBody>
       </p:sp>
       <p:sp>
         <p:nvSpPr>
@@ -20122,6 +20826,10 @@
             <a:prstDash val="solid"/>
           </a:ln>
         </p:spPr>
+        <p:txBody>
+          <a:bodyPr/>
+          <a:p/>
+        </p:txBody>
       </p:sp>
       <p:sp>
         <p:nvSpPr>
@@ -20452,6 +21160,10 @@
             <a:prstDash val="solid"/>
           </a:ln>
         </p:spPr>
+        <p:txBody>
+          <a:bodyPr/>
+          <a:p/>
+        </p:txBody>
       </p:sp>
       <p:sp>
         <p:nvSpPr>
@@ -20516,6 +21228,10 @@
             <a:prstDash val="solid"/>
           </a:ln>
         </p:spPr>
+        <p:txBody>
+          <a:bodyPr/>
+          <a:p/>
+        </p:txBody>
       </p:sp>
       <p:sp>
         <p:nvSpPr>
@@ -20541,6 +21257,10 @@
             <a:prstDash val="solid"/>
           </a:ln>
         </p:spPr>
+        <p:txBody>
+          <a:bodyPr/>
+          <a:p/>
+        </p:txBody>
       </p:sp>
       <p:sp>
         <p:nvSpPr>
@@ -20605,6 +21325,10 @@
             <a:prstDash val="solid"/>
           </a:ln>
         </p:spPr>
+        <p:txBody>
+          <a:bodyPr/>
+          <a:p/>
+        </p:txBody>
       </p:sp>
       <p:sp>
         <p:nvSpPr>
@@ -20669,6 +21393,10 @@
             <a:prstDash val="solid"/>
           </a:ln>
         </p:spPr>
+        <p:txBody>
+          <a:bodyPr/>
+          <a:p/>
+        </p:txBody>
       </p:sp>
       <p:sp>
         <p:nvSpPr>
@@ -20694,6 +21422,10 @@
             <a:prstDash val="solid"/>
           </a:ln>
         </p:spPr>
+        <p:txBody>
+          <a:bodyPr/>
+          <a:p/>
+        </p:txBody>
       </p:sp>
       <p:sp>
         <p:nvSpPr>
@@ -20758,6 +21490,10 @@
             <a:prstDash val="solid"/>
           </a:ln>
         </p:spPr>
+        <p:txBody>
+          <a:bodyPr/>
+          <a:p/>
+        </p:txBody>
       </p:sp>
       <p:sp>
         <p:nvSpPr>
@@ -20822,6 +21558,10 @@
             <a:prstDash val="solid"/>
           </a:ln>
         </p:spPr>
+        <p:txBody>
+          <a:bodyPr/>
+          <a:p/>
+        </p:txBody>
       </p:sp>
       <p:sp>
         <p:nvSpPr>
@@ -20847,6 +21587,10 @@
             <a:prstDash val="solid"/>
           </a:ln>
         </p:spPr>
+        <p:txBody>
+          <a:bodyPr/>
+          <a:p/>
+        </p:txBody>
       </p:sp>
       <p:sp>
         <p:nvSpPr>
@@ -20911,6 +21655,10 @@
             <a:prstDash val="solid"/>
           </a:ln>
         </p:spPr>
+        <p:txBody>
+          <a:bodyPr/>
+          <a:p/>
+        </p:txBody>
       </p:sp>
       <p:sp>
         <p:nvSpPr>
@@ -20975,6 +21723,10 @@
             <a:prstDash val="solid"/>
           </a:ln>
         </p:spPr>
+        <p:txBody>
+          <a:bodyPr/>
+          <a:p/>
+        </p:txBody>
       </p:sp>
       <p:sp>
         <p:nvSpPr>
@@ -21000,6 +21752,10 @@
             <a:prstDash val="solid"/>
           </a:ln>
         </p:spPr>
+        <p:txBody>
+          <a:bodyPr/>
+          <a:p/>
+        </p:txBody>
       </p:sp>
       <p:sp>
         <p:nvSpPr>
@@ -21064,6 +21820,10 @@
             <a:prstDash val="solid"/>
           </a:ln>
         </p:spPr>
+        <p:txBody>
+          <a:bodyPr/>
+          <a:p/>
+        </p:txBody>
       </p:sp>
       <p:sp>
         <p:nvSpPr>
@@ -21128,6 +21888,10 @@
             <a:prstDash val="solid"/>
           </a:ln>
         </p:spPr>
+        <p:txBody>
+          <a:bodyPr/>
+          <a:p/>
+        </p:txBody>
       </p:sp>
       <p:sp>
         <p:nvSpPr>
@@ -21153,6 +21917,10 @@
             <a:prstDash val="solid"/>
           </a:ln>
         </p:spPr>
+        <p:txBody>
+          <a:bodyPr/>
+          <a:p/>
+        </p:txBody>
       </p:sp>
       <p:sp>
         <p:nvSpPr>
@@ -21217,6 +21985,10 @@
             <a:prstDash val="solid"/>
           </a:ln>
         </p:spPr>
+        <p:txBody>
+          <a:bodyPr/>
+          <a:p/>
+        </p:txBody>
       </p:sp>
       <p:sp>
         <p:nvSpPr>
@@ -21391,6 +22163,10 @@
             <a:prstDash val="solid"/>
           </a:ln>
         </p:spPr>
+        <p:txBody>
+          <a:bodyPr/>
+          <a:p/>
+        </p:txBody>
       </p:sp>
       <p:sp>
         <p:nvSpPr>
@@ -21455,6 +22231,10 @@
             <a:prstDash val="solid"/>
           </a:ln>
         </p:spPr>
+        <p:txBody>
+          <a:bodyPr/>
+          <a:p/>
+        </p:txBody>
       </p:sp>
       <p:sp>
         <p:nvSpPr>
@@ -21480,6 +22260,10 @@
             <a:prstDash val="solid"/>
           </a:ln>
         </p:spPr>
+        <p:txBody>
+          <a:bodyPr/>
+          <a:p/>
+        </p:txBody>
       </p:sp>
       <p:sp>
         <p:nvSpPr>
@@ -21505,6 +22289,10 @@
             <a:prstDash val="solid"/>
           </a:ln>
         </p:spPr>
+        <p:txBody>
+          <a:bodyPr/>
+          <a:p/>
+        </p:txBody>
       </p:sp>
       <p:sp>
         <p:nvSpPr>
@@ -21803,6 +22591,10 @@
             <a:prstDash val="solid"/>
           </a:ln>
         </p:spPr>
+        <p:txBody>
+          <a:bodyPr/>
+          <a:p/>
+        </p:txBody>
       </p:sp>
       <p:sp>
         <p:nvSpPr>
@@ -21828,6 +22620,10 @@
             <a:prstDash val="solid"/>
           </a:ln>
         </p:spPr>
+        <p:txBody>
+          <a:bodyPr/>
+          <a:p/>
+        </p:txBody>
       </p:sp>
       <p:sp>
         <p:nvSpPr>
@@ -21853,6 +22649,10 @@
             <a:prstDash val="solid"/>
           </a:ln>
         </p:spPr>
+        <p:txBody>
+          <a:bodyPr/>
+          <a:p/>
+        </p:txBody>
       </p:sp>
       <p:sp>
         <p:nvSpPr>
@@ -22151,6 +22951,10 @@
             <a:prstDash val="solid"/>
           </a:ln>
         </p:spPr>
+        <p:txBody>
+          <a:bodyPr/>
+          <a:p/>
+        </p:txBody>
       </p:sp>
       <p:sp>
         <p:nvSpPr>
@@ -22176,6 +22980,10 @@
             <a:prstDash val="solid"/>
           </a:ln>
         </p:spPr>
+        <p:txBody>
+          <a:bodyPr/>
+          <a:p/>
+        </p:txBody>
       </p:sp>
       <p:sp>
         <p:nvSpPr>
@@ -22201,6 +23009,10 @@
             <a:prstDash val="solid"/>
           </a:ln>
         </p:spPr>
+        <p:txBody>
+          <a:bodyPr/>
+          <a:p/>
+        </p:txBody>
       </p:sp>
       <p:sp>
         <p:nvSpPr>
@@ -22609,6 +23421,10 @@
             <a:prstDash val="solid"/>
           </a:ln>
         </p:spPr>
+        <p:txBody>
+          <a:bodyPr/>
+          <a:p/>
+        </p:txBody>
       </p:sp>
       <p:sp>
         <p:nvSpPr>

</xml_diff>